<commit_message>
Add reusable MATLAB trajectory viewer
matlab/plot_trajectory.m: 3D plot + X/Y/Z-vs-time from any pipeline CSV,
auto-detecting markers from column names, with a per-marker checkbox toggling
visibility in both panels. Works for the foot pilot, wand, or future 6-marker
shoe. MATLAB is the intended plotting tool for study results.

Co-Authored-By: Claude Opus 4.8 <noreply@anthropic.com>
</commit_message>
<xml_diff>
--- a/slides/obstacle_crossing_update.pptx
+++ b/slides/obstacle_crossing_update.pptx
@@ -5,14 +5,15 @@
     <p:sldMasterId id="2147483648" r:id="rId1"/>
   </p:sldMasterIdLst>
   <p:notesMasterIdLst>
-    <p:notesMasterId r:id="rId7"/>
+    <p:notesMasterId r:id="rId8"/>
   </p:notesMasterIdLst>
   <p:sldIdLst>
     <p:sldId id="256" r:id="rId2"/>
     <p:sldId id="257" r:id="rId3"/>
     <p:sldId id="258" r:id="rId4"/>
     <p:sldId id="259" r:id="rId5"/>
-    <p:sldId id="260" r:id="rId6"/>
+    <p:sldId id="262" r:id="rId6"/>
+    <p:sldId id="260" r:id="rId7"/>
   </p:sldIdLst>
   <p:sldSz cx="12192000" cy="6858000"/>
   <p:notesSz cx="6858000" cy="12192000"/>
@@ -582,6 +583,114 @@
   <p:cSld>
     <p:spTree>
       <p:nvGrpSpPr>
+        <p:cNvPr id="1" name="">
+          <a:extLst>
+            <a:ext uri="{FF2B5EF4-FFF2-40B4-BE49-F238E27FC236}">
+              <a16:creationId xmlns:a16="http://schemas.microsoft.com/office/drawing/2014/main" id="{24F200F6-8263-A91B-C9DF-50FD874C6D42}"/>
+            </a:ext>
+          </a:extLst>
+        </p:cNvPr>
+        <p:cNvGrpSpPr/>
+        <p:nvPr/>
+      </p:nvGrpSpPr>
+      <p:grpSpPr>
+        <a:xfrm>
+          <a:off x="0" y="0"/>
+          <a:ext cx="0" cy="0"/>
+          <a:chOff x="0" y="0"/>
+          <a:chExt cx="0" cy="0"/>
+        </a:xfrm>
+      </p:grpSpPr>
+      <p:sp>
+        <p:nvSpPr>
+          <p:cNvPr id="2" name="Slide Image Placeholder 1">
+            <a:extLst>
+              <a:ext uri="{FF2B5EF4-FFF2-40B4-BE49-F238E27FC236}">
+                <a16:creationId xmlns:a16="http://schemas.microsoft.com/office/drawing/2014/main" id="{E716E1FB-7959-F5C4-4907-C97D3874839D}"/>
+              </a:ext>
+            </a:extLst>
+          </p:cNvPr>
+          <p:cNvSpPr>
+            <a:spLocks noGrp="1" noRot="1" noChangeAspect="1"/>
+          </p:cNvSpPr>
+          <p:nvPr>
+            <p:ph type="sldImg"/>
+          </p:nvPr>
+        </p:nvSpPr>
+        <p:spPr/>
+      </p:sp>
+      <p:sp>
+        <p:nvSpPr>
+          <p:cNvPr id="3" name="Notes Placeholder 2">
+            <a:extLst>
+              <a:ext uri="{FF2B5EF4-FFF2-40B4-BE49-F238E27FC236}">
+                <a16:creationId xmlns:a16="http://schemas.microsoft.com/office/drawing/2014/main" id="{22519E42-F704-3B98-F946-00E8C6F83D36}"/>
+              </a:ext>
+            </a:extLst>
+          </p:cNvPr>
+          <p:cNvSpPr>
+            <a:spLocks noGrp="1"/>
+          </p:cNvSpPr>
+          <p:nvPr>
+            <p:ph type="body" idx="1"/>
+          </p:nvPr>
+        </p:nvSpPr>
+        <p:spPr/>
+        <p:txBody>
+          <a:bodyPr/>
+          <a:lstStyle/>
+          <a:p>
+            <a:endParaRPr lang="en-US" dirty="0"/>
+          </a:p>
+        </p:txBody>
+      </p:sp>
+      <p:sp>
+        <p:nvSpPr>
+          <p:cNvPr id="4" name="Slide Number Placeholder 3">
+            <a:extLst>
+              <a:ext uri="{FF2B5EF4-FFF2-40B4-BE49-F238E27FC236}">
+                <a16:creationId xmlns:a16="http://schemas.microsoft.com/office/drawing/2014/main" id="{D2158CF0-6751-10FA-BF29-182F991F71C1}"/>
+              </a:ext>
+            </a:extLst>
+          </p:cNvPr>
+          <p:cNvSpPr>
+            <a:spLocks noGrp="1"/>
+          </p:cNvSpPr>
+          <p:nvPr>
+            <p:ph type="sldNum" sz="quarter" idx="10"/>
+          </p:nvPr>
+        </p:nvSpPr>
+        <p:spPr/>
+        <p:txBody>
+          <a:bodyPr/>
+          <a:lstStyle/>
+          <a:p>
+            <a:fld id="{F7021451-1387-4CA6-816F-3879F97B5CBC}" type="slidenum">
+              <a:rPr lang="en-US"/>
+              <a:t>5</a:t>
+            </a:fld>
+            <a:endParaRPr lang="en-US"/>
+          </a:p>
+        </p:txBody>
+      </p:sp>
+    </p:spTree>
+    <p:extLst>
+      <p:ext uri="{BB962C8B-B14F-4D97-AF65-F5344CB8AC3E}">
+        <p14:creationId xmlns:p14="http://schemas.microsoft.com/office/powerpoint/2010/main" val="2430596815"/>
+      </p:ext>
+    </p:extLst>
+  </p:cSld>
+  <p:clrMapOvr>
+    <a:masterClrMapping/>
+  </p:clrMapOvr>
+</p:notes>
+</file>
+
+<file path=ppt/notesSlides/notesSlide6.xml><?xml version="1.0" encoding="utf-8"?>
+<p:notes xmlns:a="http://schemas.openxmlformats.org/drawingml/2006/main" xmlns:r="http://schemas.openxmlformats.org/officeDocument/2006/relationships" xmlns:p="http://schemas.openxmlformats.org/presentationml/2006/main">
+  <p:cSld>
+    <p:spTree>
+      <p:nvGrpSpPr>
         <p:cNvPr id="1" name=""/>
         <p:cNvGrpSpPr/>
         <p:nvPr/>
@@ -642,7 +751,7 @@
           <a:p>
             <a:fld id="{F7021451-1387-4CA6-816F-3879F97B5CBC}" type="slidenum">
               <a:rPr lang="en-US"/>
-              <a:t>5</a:t>
+              <a:t>6</a:t>
             </a:fld>
             <a:endParaRPr lang="en-US"/>
           </a:p>
@@ -3389,6 +3498,238 @@
 </file>
 
 <file path=ppt/slides/slide5.xml><?xml version="1.0" encoding="utf-8"?>
+<p:sld xmlns:a="http://schemas.openxmlformats.org/drawingml/2006/main" xmlns:r="http://schemas.openxmlformats.org/officeDocument/2006/relationships" xmlns:p="http://schemas.openxmlformats.org/presentationml/2006/main">
+  <p:cSld>
+    <p:spTree>
+      <p:nvGrpSpPr>
+        <p:cNvPr id="1" name="">
+          <a:extLst>
+            <a:ext uri="{FF2B5EF4-FFF2-40B4-BE49-F238E27FC236}">
+              <a16:creationId xmlns:a16="http://schemas.microsoft.com/office/drawing/2014/main" id="{7AACF81A-4CD8-35D6-A3FF-504A64DE7737}"/>
+            </a:ext>
+          </a:extLst>
+        </p:cNvPr>
+        <p:cNvGrpSpPr/>
+        <p:nvPr/>
+      </p:nvGrpSpPr>
+      <p:grpSpPr>
+        <a:xfrm>
+          <a:off x="0" y="0"/>
+          <a:ext cx="0" cy="0"/>
+          <a:chOff x="0" y="0"/>
+          <a:chExt cx="0" cy="0"/>
+        </a:xfrm>
+      </p:grpSpPr>
+      <p:sp>
+        <p:nvSpPr>
+          <p:cNvPr id="2" name="Text 0">
+            <a:extLst>
+              <a:ext uri="{FF2B5EF4-FFF2-40B4-BE49-F238E27FC236}">
+                <a16:creationId xmlns:a16="http://schemas.microsoft.com/office/drawing/2014/main" id="{8E5BF64A-67EA-3A62-663C-1E338B6B80C5}"/>
+              </a:ext>
+            </a:extLst>
+          </p:cNvPr>
+          <p:cNvSpPr/>
+          <p:nvPr/>
+        </p:nvSpPr>
+        <p:spPr>
+          <a:xfrm>
+            <a:off x="640080" y="502920"/>
+            <a:ext cx="10972800" cy="640080"/>
+          </a:xfrm>
+          <a:prstGeom prst="rect">
+            <a:avLst/>
+          </a:prstGeom>
+          <a:noFill/>
+          <a:ln/>
+        </p:spPr>
+        <p:txBody>
+          <a:bodyPr wrap="square" lIns="0" tIns="0" rIns="0" bIns="0" rtlCol="0" anchor="ctr"/>
+          <a:lstStyle/>
+          <a:p>
+            <a:pPr marL="0" indent="0">
+              <a:buNone/>
+            </a:pPr>
+            <a:r>
+              <a:rPr lang="en-US" sz="3200" b="1" dirty="0">
+                <a:solidFill>
+                  <a:srgbClr val="0F2A43"/>
+                </a:solidFill>
+                <a:latin typeface="Cambria" pitchFamily="34" charset="0"/>
+                <a:ea typeface="Cambria" pitchFamily="34" charset="-122"/>
+                <a:cs typeface="Cambria" pitchFamily="34" charset="-120"/>
+              </a:rPr>
+              <a:t>Result: 3D Marker Trajectory in Motion</a:t>
+            </a:r>
+            <a:endParaRPr lang="en-US" sz="3200" dirty="0"/>
+          </a:p>
+        </p:txBody>
+      </p:sp>
+      <p:sp>
+        <p:nvSpPr>
+          <p:cNvPr id="13" name="Text 10">
+            <a:extLst>
+              <a:ext uri="{FF2B5EF4-FFF2-40B4-BE49-F238E27FC236}">
+                <a16:creationId xmlns:a16="http://schemas.microsoft.com/office/drawing/2014/main" id="{A633C137-408D-84A9-45D2-A1B00EE4FC83}"/>
+              </a:ext>
+            </a:extLst>
+          </p:cNvPr>
+          <p:cNvSpPr/>
+          <p:nvPr/>
+        </p:nvSpPr>
+        <p:spPr>
+          <a:xfrm>
+            <a:off x="640080" y="4251960"/>
+            <a:ext cx="384048" cy="384048"/>
+          </a:xfrm>
+          <a:prstGeom prst="rect">
+            <a:avLst/>
+          </a:prstGeom>
+          <a:noFill/>
+          <a:ln/>
+        </p:spPr>
+        <p:txBody>
+          <a:bodyPr wrap="square" lIns="0" tIns="0" rIns="0" bIns="0" rtlCol="0" anchor="ctr"/>
+          <a:lstStyle/>
+          <a:p>
+            <a:pPr marL="0" indent="0" algn="ctr">
+              <a:buNone/>
+            </a:pPr>
+            <a:r>
+              <a:rPr lang="en-US" sz="1600" b="1" dirty="0">
+                <a:solidFill>
+                  <a:srgbClr val="FFFFFF"/>
+                </a:solidFill>
+                <a:latin typeface="Calibri" pitchFamily="34" charset="0"/>
+                <a:ea typeface="Calibri" pitchFamily="34" charset="-122"/>
+                <a:cs typeface="Calibri" pitchFamily="34" charset="-120"/>
+              </a:rPr>
+              <a:t>3</a:t>
+            </a:r>
+            <a:endParaRPr lang="en-US" sz="1600" dirty="0"/>
+          </a:p>
+        </p:txBody>
+      </p:sp>
+      <p:sp>
+        <p:nvSpPr>
+          <p:cNvPr id="16" name="Text 13">
+            <a:extLst>
+              <a:ext uri="{FF2B5EF4-FFF2-40B4-BE49-F238E27FC236}">
+                <a16:creationId xmlns:a16="http://schemas.microsoft.com/office/drawing/2014/main" id="{25C5C483-F98B-B90A-F029-4D36F1C93B73}"/>
+              </a:ext>
+            </a:extLst>
+          </p:cNvPr>
+          <p:cNvSpPr/>
+          <p:nvPr/>
+        </p:nvSpPr>
+        <p:spPr>
+          <a:xfrm>
+            <a:off x="4297680" y="6400800"/>
+            <a:ext cx="7406640" cy="320040"/>
+          </a:xfrm>
+          <a:prstGeom prst="rect">
+            <a:avLst/>
+          </a:prstGeom>
+          <a:noFill/>
+          <a:ln/>
+        </p:spPr>
+        <p:txBody>
+          <a:bodyPr wrap="square" lIns="0" tIns="0" rIns="0" bIns="0" rtlCol="0" anchor="ctr"/>
+          <a:lstStyle/>
+          <a:p>
+            <a:pPr marL="0" indent="0" algn="ctr">
+              <a:buNone/>
+            </a:pPr>
+            <a:r>
+              <a:rPr lang="en-US" sz="1050" i="1" dirty="0">
+                <a:solidFill>
+                  <a:srgbClr val="5C6B7A"/>
+                </a:solidFill>
+                <a:latin typeface="Calibri" pitchFamily="34" charset="0"/>
+                <a:ea typeface="Calibri" pitchFamily="34" charset="-122"/>
+                <a:cs typeface="Calibri" pitchFamily="34" charset="-120"/>
+              </a:rPr>
+              <a:t>Top: reconstructed distances stay on the known values (dotted).  Bottom: the markers' 3D paths.</a:t>
+            </a:r>
+            <a:endParaRPr lang="en-US" sz="1050" dirty="0"/>
+          </a:p>
+        </p:txBody>
+      </p:sp>
+      <p:pic>
+        <p:nvPicPr>
+          <p:cNvPr id="18" name="Picture 17">
+            <a:extLst>
+              <a:ext uri="{FF2B5EF4-FFF2-40B4-BE49-F238E27FC236}">
+                <a16:creationId xmlns:a16="http://schemas.microsoft.com/office/drawing/2014/main" id="{5B10A5B2-D53A-7345-38E3-0E19BA783485}"/>
+              </a:ext>
+            </a:extLst>
+          </p:cNvPr>
+          <p:cNvPicPr>
+            <a:picLocks noChangeAspect="1"/>
+          </p:cNvPicPr>
+          <p:nvPr/>
+        </p:nvPicPr>
+        <p:blipFill>
+          <a:blip r:embed="rId3"/>
+          <a:srcRect l="15478" r="18437" b="28306"/>
+          <a:stretch>
+            <a:fillRect/>
+          </a:stretch>
+        </p:blipFill>
+        <p:spPr>
+          <a:xfrm>
+            <a:off x="279918" y="1807573"/>
+            <a:ext cx="5314122" cy="3242854"/>
+          </a:xfrm>
+          <a:prstGeom prst="rect">
+            <a:avLst/>
+          </a:prstGeom>
+        </p:spPr>
+      </p:pic>
+      <p:pic>
+        <p:nvPicPr>
+          <p:cNvPr id="20" name="Picture 19">
+            <a:extLst>
+              <a:ext uri="{FF2B5EF4-FFF2-40B4-BE49-F238E27FC236}">
+                <a16:creationId xmlns:a16="http://schemas.microsoft.com/office/drawing/2014/main" id="{A134777F-D128-7F77-D8FE-3BBF6A8CF7C6}"/>
+              </a:ext>
+            </a:extLst>
+          </p:cNvPr>
+          <p:cNvPicPr>
+            <a:picLocks noChangeAspect="1"/>
+          </p:cNvPicPr>
+          <p:nvPr/>
+        </p:nvPicPr>
+        <p:blipFill>
+          <a:blip r:embed="rId4"/>
+          <a:stretch>
+            <a:fillRect/>
+          </a:stretch>
+        </p:blipFill>
+        <p:spPr>
+          <a:xfrm>
+            <a:off x="5999583" y="1418253"/>
+            <a:ext cx="5296483" cy="3851988"/>
+          </a:xfrm>
+          <a:prstGeom prst="rect">
+            <a:avLst/>
+          </a:prstGeom>
+        </p:spPr>
+      </p:pic>
+    </p:spTree>
+    <p:extLst>
+      <p:ext uri="{BB962C8B-B14F-4D97-AF65-F5344CB8AC3E}">
+        <p14:creationId xmlns:p14="http://schemas.microsoft.com/office/powerpoint/2010/main" val="1163670378"/>
+      </p:ext>
+    </p:extLst>
+  </p:cSld>
+  <p:clrMapOvr>
+    <a:masterClrMapping/>
+  </p:clrMapOvr>
+</p:sld>
+</file>
+
+<file path=ppt/slides/slide6.xml><?xml version="1.0" encoding="utf-8"?>
 <p:sld xmlns:a="http://schemas.openxmlformats.org/drawingml/2006/main" xmlns:r="http://schemas.openxmlformats.org/officeDocument/2006/relationships" xmlns:p="http://schemas.openxmlformats.org/presentationml/2006/main">
   <p:cSld name="Slide 5">
     <p:bg>

</xml_diff>

<commit_message>
Remove superseded scripts + refresh code-structure doc
Dead leaf scripts (nothing imports them; replaced by the current pipeline):
- solve_stereo_robust.py, diag_stereo.py  -> superseded by run_stereo_ransac
- detect_board_holds.py                    -> hold detection now inside run_stereo_ransac
- compute_worldframe.py                    -> world transform now in build_calibration;
                                              CSV->world done inline in build_foot_trajectory

Kept: core workflow (build_foot_trajectory, build_calibration, run_stereo_ransac,
run_stereo[scan]), intrinsics scripts, validation (run_rod_test, build_wand_trajectory),
all occ modules. docs/code-structure.md updated to match (sessions/, wrappers, audiosync,
purple/green markers). Verified imports + no remaining references.

Co-Authored-By: Claude Opus 4.8 <noreply@anthropic.com>
</commit_message>
<xml_diff>
--- a/slides/obstacle_crossing_update.pptx
+++ b/slides/obstacle_crossing_update.pptx
@@ -4,17 +4,18 @@
   <p:sldMasterIdLst>
     <p:sldMasterId id="2147483648" r:id="rId1"/>
   </p:sldMasterIdLst>
+  <p:notesMasterIdLst>
+    <p:notesMasterId r:id="rId9"/>
+  </p:notesMasterIdLst>
   <p:sldIdLst>
     <p:sldId id="256" r:id="rId2"/>
     <p:sldId id="257" r:id="rId3"/>
     <p:sldId id="258" r:id="rId4"/>
     <p:sldId id="259" r:id="rId5"/>
     <p:sldId id="260" r:id="rId6"/>
-    <p:sldId id="261" r:id="rId7"/>
+    <p:sldId id="262" r:id="rId7"/>
+    <p:sldId id="261" r:id="rId8"/>
   </p:sldIdLst>
-  <p:notesMasterIdLst>
-    <p:notesMasterId r:id="rId8"/>
-  </p:notesMasterIdLst>
   <p:sldSz cx="12192000" cy="6858000"/>
   <p:notesSz cx="6858000" cy="12192000"/>
   <p:defaultTextStyle>
@@ -109,6 +110,11 @@
       </a:defRPr>
     </a:lvl9pPr>
   </p:defaultTextStyle>
+  <p:extLst>
+    <p:ext uri="{EFAFB233-063F-42B5-8137-9DF3F51BA10A}">
+      <p15:sldGuideLst xmlns:p15="http://schemas.microsoft.com/office/powerpoint/2012/main"/>
+    </p:ext>
+  </p:extLst>
 </p:presentation>
 </file>
 
@@ -134,234 +140,10 @@
           <a:chExt cx="0" cy="0"/>
         </a:xfrm>
       </p:grpSpPr>
-      <p:sp>
-        <p:nvSpPr>
-          <p:cNvPr id="2" name="Header Placeholder 1"/>
-          <p:cNvSpPr>
-            <a:spLocks noGrp="1"/>
-          </p:cNvSpPr>
-          <p:nvPr>
-            <p:ph type="hdr" sz="quarter"/>
-          </p:nvPr>
-        </p:nvSpPr>
-        <p:spPr>
-          <a:xfrm>
-            <a:off x="0" y="0"/>
-            <a:ext cx="2971800" cy="458788"/>
-          </a:xfrm>
-          <a:prstGeom prst="rect">
-            <a:avLst/>
-          </a:prstGeom>
-        </p:spPr>
-        <p:txBody>
-          <a:bodyPr vert="horz" lIns="91440" tIns="45720" rIns="91440" bIns="45720" rtlCol="0"/>
-          <a:lstStyle>
-            <a:lvl1pPr algn="l">
-              <a:defRPr sz="1200"/>
-            </a:lvl1pPr>
-          </a:lstStyle>
-          <a:p>
-            <a:endParaRPr lang="en-US"/>
-          </a:p>
-        </p:txBody>
-      </p:sp>
-      <p:sp>
-        <p:nvSpPr>
-          <p:cNvPr id="3" name="Date Placeholder 2"/>
-          <p:cNvSpPr>
-            <a:spLocks noGrp="1"/>
-          </p:cNvSpPr>
-          <p:nvPr>
-            <p:ph type="dt" idx="1"/>
-          </p:nvPr>
-        </p:nvSpPr>
-        <p:spPr>
-          <a:xfrm>
-            <a:off x="3884613" y="0"/>
-            <a:ext cx="2971800" cy="458788"/>
-          </a:xfrm>
-          <a:prstGeom prst="rect">
-            <a:avLst/>
-          </a:prstGeom>
-        </p:spPr>
-        <p:txBody>
-          <a:bodyPr vert="horz" lIns="91440" tIns="45720" rIns="91440" bIns="45720" rtlCol="0"/>
-          <a:lstStyle>
-            <a:lvl1pPr algn="r">
-              <a:defRPr sz="1200"/>
-            </a:lvl1pPr>
-          </a:lstStyle>
-          <a:p>
-            <a:fld id="{5282F153-3F37-0F45-9E97-73ACFA13230C}" type="datetimeFigureOut">
-              <a:rPr lang="en-US"/>
-              <a:t>7/23/19</a:t>
-            </a:fld>
-            <a:endParaRPr lang="en-US"/>
-          </a:p>
-        </p:txBody>
-      </p:sp>
-      <p:sp>
-        <p:nvSpPr>
-          <p:cNvPr id="4" name="Slide Image Placeholder 3"/>
-          <p:cNvSpPr>
-            <a:spLocks noGrp="1" noRot="1" noChangeAspect="1"/>
-          </p:cNvSpPr>
-          <p:nvPr>
-            <p:ph type="sldImg" idx="2"/>
-          </p:nvPr>
-        </p:nvSpPr>
-        <p:spPr>
-          <a:xfrm>
-            <a:off x="685800" y="1143000"/>
-            <a:ext cx="5486400" cy="3086100"/>
-          </a:xfrm>
-          <a:prstGeom prst="rect">
-            <a:avLst/>
-          </a:prstGeom>
-          <a:noFill/>
-          <a:ln w="12700">
-            <a:solidFill>
-              <a:prstClr val="black"/>
-            </a:solidFill>
-          </a:ln>
-        </p:spPr>
-        <p:txBody>
-          <a:bodyPr vert="horz" lIns="91440" tIns="45720" rIns="91440" bIns="45720" rtlCol="0" anchor="ctr"/>
-          <a:lstStyle/>
-          <a:p>
-            <a:endParaRPr lang="en-US"/>
-          </a:p>
-        </p:txBody>
-      </p:sp>
-      <p:sp>
-        <p:nvSpPr>
-          <p:cNvPr id="5" name="Notes Placeholder 4"/>
-          <p:cNvSpPr>
-            <a:spLocks noGrp="1"/>
-          </p:cNvSpPr>
-          <p:nvPr>
-            <p:ph type="body" sz="quarter" idx="3"/>
-          </p:nvPr>
-        </p:nvSpPr>
-        <p:spPr>
-          <a:xfrm>
-            <a:off x="685800" y="4400550"/>
-            <a:ext cx="5486400" cy="3600450"/>
-          </a:xfrm>
-          <a:prstGeom prst="rect">
-            <a:avLst/>
-          </a:prstGeom>
-        </p:spPr>
-        <p:txBody>
-          <a:bodyPr vert="horz" lIns="91440" tIns="45720" rIns="91440" bIns="45720" rtlCol="0"/>
-          <a:lstStyle/>
-          <a:p>
-            <a:pPr lvl="0"/>
-            <a:r>
-              <a:rPr lang="en-US"/>
-              <a:t>Click to edit Master text styles</a:t>
-            </a:r>
-          </a:p>
-          <a:p>
-            <a:pPr lvl="1"/>
-            <a:r>
-              <a:rPr lang="en-US"/>
-              <a:t>Second level</a:t>
-            </a:r>
-          </a:p>
-          <a:p>
-            <a:pPr lvl="2"/>
-            <a:r>
-              <a:rPr lang="en-US"/>
-              <a:t>Third level</a:t>
-            </a:r>
-          </a:p>
-          <a:p>
-            <a:pPr lvl="3"/>
-            <a:r>
-              <a:rPr lang="en-US"/>
-              <a:t>Fourth level</a:t>
-            </a:r>
-          </a:p>
-          <a:p>
-            <a:pPr lvl="4"/>
-            <a:r>
-              <a:rPr lang="en-US"/>
-              <a:t>Fifth level</a:t>
-            </a:r>
-          </a:p>
-        </p:txBody>
-      </p:sp>
-      <p:sp>
-        <p:nvSpPr>
-          <p:cNvPr id="6" name="Footer Placeholder 5"/>
-          <p:cNvSpPr>
-            <a:spLocks noGrp="1"/>
-          </p:cNvSpPr>
-          <p:nvPr>
-            <p:ph type="ftr" sz="quarter" idx="4"/>
-          </p:nvPr>
-        </p:nvSpPr>
-        <p:spPr>
-          <a:xfrm>
-            <a:off x="0" y="8685213"/>
-            <a:ext cx="2971800" cy="458787"/>
-          </a:xfrm>
-          <a:prstGeom prst="rect">
-            <a:avLst/>
-          </a:prstGeom>
-        </p:spPr>
-        <p:txBody>
-          <a:bodyPr vert="horz" lIns="91440" tIns="45720" rIns="91440" bIns="45720" rtlCol="0" anchor="b"/>
-          <a:lstStyle>
-            <a:lvl1pPr algn="l">
-              <a:defRPr sz="1200"/>
-            </a:lvl1pPr>
-          </a:lstStyle>
-          <a:p>
-            <a:endParaRPr lang="en-US"/>
-          </a:p>
-        </p:txBody>
-      </p:sp>
-      <p:sp>
-        <p:nvSpPr>
-          <p:cNvPr id="7" name="Slide Number Placeholder 6"/>
-          <p:cNvSpPr>
-            <a:spLocks noGrp="1"/>
-          </p:cNvSpPr>
-          <p:nvPr>
-            <p:ph type="sldNum" sz="quarter" idx="5"/>
-          </p:nvPr>
-        </p:nvSpPr>
-        <p:spPr>
-          <a:xfrm>
-            <a:off x="3884613" y="8685213"/>
-            <a:ext cx="2971800" cy="458787"/>
-          </a:xfrm>
-          <a:prstGeom prst="rect">
-            <a:avLst/>
-          </a:prstGeom>
-        </p:spPr>
-        <p:txBody>
-          <a:bodyPr vert="horz" lIns="91440" tIns="45720" rIns="91440" bIns="45720" rtlCol="0" anchor="b"/>
-          <a:lstStyle>
-            <a:lvl1pPr algn="r">
-              <a:defRPr sz="1200"/>
-            </a:lvl1pPr>
-          </a:lstStyle>
-          <a:p>
-            <a:fld id="{CE5E9CC1-C706-0F49-92D6-E571CC5EEA8F}" type="slidenum">
-              <a:rPr lang="en-US"/>
-              <a:t>‹#›</a:t>
-            </a:fld>
-            <a:endParaRPr lang="en-US"/>
-          </a:p>
-        </p:txBody>
-      </p:sp>
     </p:spTree>
     <p:extLst>
       <p:ext uri="{BB962C8B-B14F-4D97-AF65-F5344CB8AC3E}">
-        <p14:creationId xmlns:p14="http://schemas.microsoft.com/office/powerpoint/2010/main" val="1024086991"/>
+        <p14:creationId xmlns:p14="http://schemas.microsoft.com/office/powerpoint/2010/main" val="2499956107"/>
       </p:ext>
     </p:extLst>
   </p:cSld>
@@ -505,10 +287,6 @@
           <a:bodyPr/>
           <a:lstStyle/>
           <a:p>
-            <a:r>
-              <a:rPr lang="en-US" dirty="0"/>
-              <a:t/>
-            </a:r>
             <a:endParaRPr lang="en-US" dirty="0"/>
           </a:p>
         </p:txBody>
@@ -593,10 +371,6 @@
           <a:bodyPr/>
           <a:lstStyle/>
           <a:p>
-            <a:r>
-              <a:rPr lang="en-US" dirty="0"/>
-              <a:t/>
-            </a:r>
             <a:endParaRPr lang="en-US" dirty="0"/>
           </a:p>
         </p:txBody>
@@ -681,10 +455,6 @@
           <a:bodyPr/>
           <a:lstStyle/>
           <a:p>
-            <a:r>
-              <a:rPr lang="en-US" dirty="0"/>
-              <a:t/>
-            </a:r>
             <a:endParaRPr lang="en-US" dirty="0"/>
           </a:p>
         </p:txBody>
@@ -769,10 +539,6 @@
           <a:bodyPr/>
           <a:lstStyle/>
           <a:p>
-            <a:r>
-              <a:rPr lang="en-US" dirty="0"/>
-              <a:t/>
-            </a:r>
             <a:endParaRPr lang="en-US" dirty="0"/>
           </a:p>
         </p:txBody>
@@ -857,10 +623,6 @@
           <a:bodyPr/>
           <a:lstStyle/>
           <a:p>
-            <a:r>
-              <a:rPr lang="en-US" dirty="0"/>
-              <a:t/>
-            </a:r>
             <a:endParaRPr lang="en-US" dirty="0"/>
           </a:p>
         </p:txBody>
@@ -906,6 +668,114 @@
   <p:cSld>
     <p:spTree>
       <p:nvGrpSpPr>
+        <p:cNvPr id="1" name="">
+          <a:extLst>
+            <a:ext uri="{FF2B5EF4-FFF2-40B4-BE49-F238E27FC236}">
+              <a16:creationId xmlns:a16="http://schemas.microsoft.com/office/drawing/2014/main" id="{0E82E7F3-E778-C66B-6E31-3FD6A1E0892C}"/>
+            </a:ext>
+          </a:extLst>
+        </p:cNvPr>
+        <p:cNvGrpSpPr/>
+        <p:nvPr/>
+      </p:nvGrpSpPr>
+      <p:grpSpPr>
+        <a:xfrm>
+          <a:off x="0" y="0"/>
+          <a:ext cx="0" cy="0"/>
+          <a:chOff x="0" y="0"/>
+          <a:chExt cx="0" cy="0"/>
+        </a:xfrm>
+      </p:grpSpPr>
+      <p:sp>
+        <p:nvSpPr>
+          <p:cNvPr id="2" name="Slide Image Placeholder 1">
+            <a:extLst>
+              <a:ext uri="{FF2B5EF4-FFF2-40B4-BE49-F238E27FC236}">
+                <a16:creationId xmlns:a16="http://schemas.microsoft.com/office/drawing/2014/main" id="{C2180871-DCD8-8E06-7DAE-B9631E616311}"/>
+              </a:ext>
+            </a:extLst>
+          </p:cNvPr>
+          <p:cNvSpPr>
+            <a:spLocks noGrp="1" noRot="1" noChangeAspect="1"/>
+          </p:cNvSpPr>
+          <p:nvPr>
+            <p:ph type="sldImg"/>
+          </p:nvPr>
+        </p:nvSpPr>
+        <p:spPr/>
+      </p:sp>
+      <p:sp>
+        <p:nvSpPr>
+          <p:cNvPr id="3" name="Notes Placeholder 2">
+            <a:extLst>
+              <a:ext uri="{FF2B5EF4-FFF2-40B4-BE49-F238E27FC236}">
+                <a16:creationId xmlns:a16="http://schemas.microsoft.com/office/drawing/2014/main" id="{3404F576-2AAF-CE54-7135-22F56C859547}"/>
+              </a:ext>
+            </a:extLst>
+          </p:cNvPr>
+          <p:cNvSpPr>
+            <a:spLocks noGrp="1"/>
+          </p:cNvSpPr>
+          <p:nvPr>
+            <p:ph type="body" idx="1"/>
+          </p:nvPr>
+        </p:nvSpPr>
+        <p:spPr/>
+        <p:txBody>
+          <a:bodyPr/>
+          <a:lstStyle/>
+          <a:p>
+            <a:endParaRPr lang="en-US" dirty="0"/>
+          </a:p>
+        </p:txBody>
+      </p:sp>
+      <p:sp>
+        <p:nvSpPr>
+          <p:cNvPr id="4" name="Slide Number Placeholder 3">
+            <a:extLst>
+              <a:ext uri="{FF2B5EF4-FFF2-40B4-BE49-F238E27FC236}">
+                <a16:creationId xmlns:a16="http://schemas.microsoft.com/office/drawing/2014/main" id="{51F14B11-A664-2C89-32D0-62994C94B352}"/>
+              </a:ext>
+            </a:extLst>
+          </p:cNvPr>
+          <p:cNvSpPr>
+            <a:spLocks noGrp="1"/>
+          </p:cNvSpPr>
+          <p:nvPr>
+            <p:ph type="sldNum" sz="quarter" idx="10"/>
+          </p:nvPr>
+        </p:nvSpPr>
+        <p:spPr/>
+        <p:txBody>
+          <a:bodyPr/>
+          <a:lstStyle/>
+          <a:p>
+            <a:fld id="{F7021451-1387-4CA6-816F-3879F97B5CBC}" type="slidenum">
+              <a:rPr lang="en-US"/>
+              <a:t>6</a:t>
+            </a:fld>
+            <a:endParaRPr lang="en-US"/>
+          </a:p>
+        </p:txBody>
+      </p:sp>
+    </p:spTree>
+    <p:extLst>
+      <p:ext uri="{BB962C8B-B14F-4D97-AF65-F5344CB8AC3E}">
+        <p14:creationId xmlns:p14="http://schemas.microsoft.com/office/powerpoint/2010/main" val="3250153263"/>
+      </p:ext>
+    </p:extLst>
+  </p:cSld>
+  <p:clrMapOvr>
+    <a:masterClrMapping/>
+  </p:clrMapOvr>
+</p:notes>
+</file>
+
+<file path=ppt/notesSlides/notesSlide7.xml><?xml version="1.0" encoding="utf-8"?>
+<p:notes xmlns:a="http://schemas.openxmlformats.org/drawingml/2006/main" xmlns:r="http://schemas.openxmlformats.org/officeDocument/2006/relationships" xmlns:p="http://schemas.openxmlformats.org/presentationml/2006/main">
+  <p:cSld>
+    <p:spTree>
+      <p:nvGrpSpPr>
         <p:cNvPr id="1" name=""/>
         <p:cNvGrpSpPr/>
         <p:nvPr/>
@@ -945,10 +815,6 @@
           <a:bodyPr/>
           <a:lstStyle/>
           <a:p>
-            <a:r>
-              <a:rPr lang="en-US" dirty="0"/>
-              <a:t/>
-            </a:r>
             <a:endParaRPr lang="en-US" dirty="0"/>
           </a:p>
         </p:txBody>
@@ -970,7 +836,7 @@
           <a:p>
             <a:fld id="{F7021451-1387-4CA6-816F-3879F97B5CBC}" type="slidenum">
               <a:rPr lang="en-US"/>
-              <a:t>6</a:t>
+              <a:t>7</a:t>
             </a:fld>
             <a:endParaRPr lang="en-US"/>
           </a:p>
@@ -1022,6 +888,11 @@
 <file path=ppt/slideMasters/slideMaster1.xml><?xml version="1.0" encoding="utf-8"?>
 <p:sldMaster xmlns:a="http://schemas.openxmlformats.org/drawingml/2006/main" xmlns:r="http://schemas.openxmlformats.org/officeDocument/2006/relationships" xmlns:p="http://schemas.openxmlformats.org/presentationml/2006/main">
   <p:cSld>
+    <p:bg>
+      <p:bgRef idx="1001">
+        <a:schemeClr val="bg1"/>
+      </p:bgRef>
+    </p:bg>
     <p:spTree>
       <p:nvGrpSpPr>
         <p:cNvPr id="1" name=""/>
@@ -1304,6 +1175,7 @@
         <a:solidFill>
           <a:srgbClr val="0F2A43"/>
         </a:solidFill>
+        <a:effectLst/>
       </p:bgPr>
     </p:bg>
     <p:spTree>
@@ -1322,15 +1194,15 @@
       </p:grpSpPr>
       <p:pic>
         <p:nvPicPr>
-          <p:cNvPr id="2" name="Image 0" descr="img/crossing_hero.jpg">    </p:cNvPr>
+          <p:cNvPr id="2" name="Image 0" descr="img/crossing_hero.jpg"/>
           <p:cNvPicPr>
             <a:picLocks noChangeAspect="1"/>
           </p:cNvPicPr>
           <p:nvPr/>
         </p:nvPicPr>
         <p:blipFill>
-          <a:blip r:embed="rId1"/>
-          <a:srcRect l="0" r="0" t="0" b="0"/>
+          <a:blip r:embed="rId3"/>
+          <a:srcRect/>
           <a:stretch/>
         </p:blipFill>
         <p:spPr>
@@ -1362,6 +1234,13 @@
           </a:solidFill>
           <a:ln/>
         </p:spPr>
+        <p:txBody>
+          <a:bodyPr/>
+          <a:lstStyle/>
+          <a:p>
+            <a:endParaRPr lang="en-US"/>
+          </a:p>
+        </p:txBody>
       </p:sp>
       <p:sp>
         <p:nvSpPr>
@@ -1384,6 +1263,13 @@
           </a:solidFill>
           <a:ln/>
         </p:spPr>
+        <p:txBody>
+          <a:bodyPr/>
+          <a:lstStyle/>
+          <a:p>
+            <a:endParaRPr lang="en-US"/>
+          </a:p>
+        </p:txBody>
       </p:sp>
       <p:sp>
         <p:nvSpPr>
@@ -1406,11 +1292,11 @@
           <a:bodyPr wrap="square" lIns="0" tIns="0" rIns="0" bIns="0" rtlCol="0" anchor="ctr"/>
           <a:lstStyle/>
           <a:p>
-            <a:pPr indent="0" marL="0">
+            <a:pPr marL="0" indent="0">
               <a:buNone/>
             </a:pPr>
             <a:r>
-              <a:rPr lang="en-US" sz="1350" b="1" spc="300" kern="0" dirty="0">
+              <a:rPr lang="en-US" sz="1350" b="1" kern="0" spc="300" dirty="0">
                 <a:solidFill>
                   <a:srgbClr val="2EC4B6"/>
                 </a:solidFill>
@@ -1445,7 +1331,7 @@
           <a:bodyPr wrap="square" lIns="0" tIns="0" rIns="0" bIns="0" rtlCol="0" anchor="ctr"/>
           <a:lstStyle/>
           <a:p>
-            <a:pPr indent="0" marL="0">
+            <a:pPr marL="0" indent="0">
               <a:lnSpc>
                 <a:spcPct val="105000"/>
               </a:lnSpc>
@@ -1465,7 +1351,7 @@
             <a:endParaRPr lang="en-US" sz="3300" dirty="0"/>
           </a:p>
           <a:p>
-            <a:pPr indent="0" marL="0">
+            <a:pPr marL="0" indent="0">
               <a:lnSpc>
                 <a:spcPct val="105000"/>
               </a:lnSpc>
@@ -1507,7 +1393,7 @@
           <a:bodyPr wrap="square" lIns="0" tIns="0" rIns="0" bIns="0" rtlCol="0" anchor="ctr"/>
           <a:lstStyle/>
           <a:p>
-            <a:pPr indent="0" marL="0">
+            <a:pPr marL="0" indent="0">
               <a:lnSpc>
                 <a:spcPct val="112000"/>
               </a:lnSpc>
@@ -1549,7 +1435,7 @@
           <a:bodyPr wrap="square" lIns="0" tIns="0" rIns="0" bIns="0" rtlCol="0" anchor="ctr"/>
           <a:lstStyle/>
           <a:p>
-            <a:pPr indent="0" marL="0">
+            <a:pPr marL="0" indent="0">
               <a:buNone/>
             </a:pPr>
             <a:r>
@@ -1563,9 +1449,6 @@
               </a:rPr>
               <a:t>Ehsan Sharafian</a:t>
             </a:r>
-            <a:pPr indent="0" marL="0">
-              <a:buNone/>
-            </a:pPr>
             <a:r>
               <a:rPr lang="en-US" sz="1300" dirty="0">
                 <a:solidFill>
@@ -1597,6 +1480,7 @@
         <a:solidFill>
           <a:srgbClr val="F4F7FA"/>
         </a:solidFill>
+        <a:effectLst/>
       </p:bgPr>
     </p:bg>
     <p:spTree>
@@ -1634,7 +1518,7 @@
           <a:bodyPr wrap="square" lIns="0" tIns="0" rIns="0" bIns="0" rtlCol="0" anchor="ctr"/>
           <a:lstStyle/>
           <a:p>
-            <a:pPr indent="0" marL="0">
+            <a:pPr marL="0" indent="0">
               <a:buNone/>
             </a:pPr>
             <a:r>
@@ -1671,6 +1555,13 @@
           </a:solidFill>
           <a:ln/>
         </p:spPr>
+        <p:txBody>
+          <a:bodyPr/>
+          <a:lstStyle/>
+          <a:p>
+            <a:endParaRPr lang="en-US"/>
+          </a:p>
+        </p:txBody>
       </p:sp>
       <p:sp>
         <p:nvSpPr>
@@ -1698,13 +1589,20 @@
             <a:prstDash val="solid"/>
           </a:ln>
           <a:effectLst>
-            <a:outerShdw sx="100000" sy="100000" kx="0" ky="0" algn="bl" rotWithShape="0" blurRad="101600" dist="38100" dir="5400000">
+            <a:outerShdw blurRad="101600" dist="38100" dir="5400000" algn="bl" rotWithShape="0">
               <a:srgbClr val="20344A">
                 <a:alpha val="28000"/>
               </a:srgbClr>
             </a:outerShdw>
           </a:effectLst>
         </p:spPr>
+        <p:txBody>
+          <a:bodyPr/>
+          <a:lstStyle/>
+          <a:p>
+            <a:endParaRPr lang="en-US"/>
+          </a:p>
+        </p:txBody>
       </p:sp>
       <p:sp>
         <p:nvSpPr>
@@ -1725,6 +1623,13 @@
           </a:solidFill>
           <a:ln/>
         </p:spPr>
+        <p:txBody>
+          <a:bodyPr/>
+          <a:lstStyle/>
+          <a:p>
+            <a:endParaRPr lang="en-US"/>
+          </a:p>
+        </p:txBody>
       </p:sp>
       <p:sp>
         <p:nvSpPr>
@@ -1747,7 +1652,7 @@
           <a:bodyPr wrap="square" lIns="0" tIns="0" rIns="0" bIns="0" rtlCol="0" anchor="ctr"/>
           <a:lstStyle/>
           <a:p>
-            <a:pPr indent="0" marL="0">
+            <a:pPr marL="0" indent="0">
               <a:buNone/>
             </a:pPr>
             <a:r>
@@ -1786,7 +1691,7 @@
           <a:bodyPr wrap="square" lIns="0" tIns="0" rIns="0" bIns="0" rtlCol="0" anchor="ctr"/>
           <a:lstStyle/>
           <a:p>
-            <a:pPr indent="0" marL="0">
+            <a:pPr marL="0" indent="0">
               <a:buNone/>
             </a:pPr>
             <a:r>
@@ -1830,13 +1735,20 @@
             <a:prstDash val="solid"/>
           </a:ln>
           <a:effectLst>
-            <a:outerShdw sx="100000" sy="100000" kx="0" ky="0" algn="bl" rotWithShape="0" blurRad="101600" dist="38100" dir="5400000">
+            <a:outerShdw blurRad="101600" dist="38100" dir="5400000" algn="bl" rotWithShape="0">
               <a:srgbClr val="20344A">
                 <a:alpha val="28000"/>
               </a:srgbClr>
             </a:outerShdw>
           </a:effectLst>
         </p:spPr>
+        <p:txBody>
+          <a:bodyPr/>
+          <a:lstStyle/>
+          <a:p>
+            <a:endParaRPr lang="en-US"/>
+          </a:p>
+        </p:txBody>
       </p:sp>
       <p:sp>
         <p:nvSpPr>
@@ -1857,6 +1769,13 @@
           </a:solidFill>
           <a:ln/>
         </p:spPr>
+        <p:txBody>
+          <a:bodyPr/>
+          <a:lstStyle/>
+          <a:p>
+            <a:endParaRPr lang="en-US"/>
+          </a:p>
+        </p:txBody>
       </p:sp>
       <p:sp>
         <p:nvSpPr>
@@ -1879,7 +1798,7 @@
           <a:bodyPr wrap="square" lIns="0" tIns="0" rIns="0" bIns="0" rtlCol="0" anchor="ctr"/>
           <a:lstStyle/>
           <a:p>
-            <a:pPr indent="0" marL="0">
+            <a:pPr marL="0" indent="0">
               <a:buNone/>
             </a:pPr>
             <a:r>
@@ -1918,7 +1837,7 @@
           <a:bodyPr wrap="square" lIns="0" tIns="0" rIns="0" bIns="0" rtlCol="0" anchor="ctr"/>
           <a:lstStyle/>
           <a:p>
-            <a:pPr indent="0" marL="0">
+            <a:pPr marL="0" indent="0">
               <a:buNone/>
             </a:pPr>
             <a:r>
@@ -1962,13 +1881,20 @@
             <a:prstDash val="solid"/>
           </a:ln>
           <a:effectLst>
-            <a:outerShdw sx="100000" sy="100000" kx="0" ky="0" algn="bl" rotWithShape="0" blurRad="101600" dist="38100" dir="5400000">
+            <a:outerShdw blurRad="101600" dist="38100" dir="5400000" algn="bl" rotWithShape="0">
               <a:srgbClr val="20344A">
                 <a:alpha val="28000"/>
               </a:srgbClr>
             </a:outerShdw>
           </a:effectLst>
         </p:spPr>
+        <p:txBody>
+          <a:bodyPr/>
+          <a:lstStyle/>
+          <a:p>
+            <a:endParaRPr lang="en-US"/>
+          </a:p>
+        </p:txBody>
       </p:sp>
       <p:sp>
         <p:nvSpPr>
@@ -1989,6 +1915,13 @@
           </a:solidFill>
           <a:ln/>
         </p:spPr>
+        <p:txBody>
+          <a:bodyPr/>
+          <a:lstStyle/>
+          <a:p>
+            <a:endParaRPr lang="en-US"/>
+          </a:p>
+        </p:txBody>
       </p:sp>
       <p:sp>
         <p:nvSpPr>
@@ -2011,7 +1944,7 @@
           <a:bodyPr wrap="square" lIns="0" tIns="0" rIns="0" bIns="0" rtlCol="0" anchor="ctr"/>
           <a:lstStyle/>
           <a:p>
-            <a:pPr indent="0" marL="0">
+            <a:pPr marL="0" indent="0">
               <a:buNone/>
             </a:pPr>
             <a:r>
@@ -2050,7 +1983,7 @@
           <a:bodyPr wrap="square" lIns="0" tIns="0" rIns="0" bIns="0" rtlCol="0" anchor="ctr"/>
           <a:lstStyle/>
           <a:p>
-            <a:pPr indent="0" marL="0">
+            <a:pPr marL="0" indent="0">
               <a:buNone/>
             </a:pPr>
             <a:r>
@@ -2094,13 +2027,20 @@
             <a:prstDash val="solid"/>
           </a:ln>
           <a:effectLst>
-            <a:outerShdw sx="100000" sy="100000" kx="0" ky="0" algn="bl" rotWithShape="0" blurRad="101600" dist="38100" dir="5400000">
+            <a:outerShdw blurRad="101600" dist="38100" dir="5400000" algn="bl" rotWithShape="0">
               <a:srgbClr val="20344A">
                 <a:alpha val="28000"/>
               </a:srgbClr>
             </a:outerShdw>
           </a:effectLst>
         </p:spPr>
+        <p:txBody>
+          <a:bodyPr/>
+          <a:lstStyle/>
+          <a:p>
+            <a:endParaRPr lang="en-US"/>
+          </a:p>
+        </p:txBody>
       </p:sp>
       <p:sp>
         <p:nvSpPr>
@@ -2121,6 +2061,13 @@
           </a:solidFill>
           <a:ln/>
         </p:spPr>
+        <p:txBody>
+          <a:bodyPr/>
+          <a:lstStyle/>
+          <a:p>
+            <a:endParaRPr lang="en-US"/>
+          </a:p>
+        </p:txBody>
       </p:sp>
       <p:sp>
         <p:nvSpPr>
@@ -2143,7 +2090,7 @@
           <a:bodyPr wrap="square" lIns="0" tIns="0" rIns="0" bIns="0" rtlCol="0" anchor="ctr"/>
           <a:lstStyle/>
           <a:p>
-            <a:pPr indent="0" marL="0">
+            <a:pPr marL="0" indent="0">
               <a:buNone/>
             </a:pPr>
             <a:r>
@@ -2182,7 +2129,7 @@
           <a:bodyPr wrap="square" lIns="0" tIns="0" rIns="0" bIns="0" rtlCol="0" anchor="ctr"/>
           <a:lstStyle/>
           <a:p>
-            <a:pPr indent="0" marL="0">
+            <a:pPr marL="0" indent="0">
               <a:buNone/>
             </a:pPr>
             <a:r>
@@ -2202,15 +2149,15 @@
       </p:sp>
       <p:pic>
         <p:nvPicPr>
-          <p:cNvPr id="20" name="Image 0" descr="img/markers_closeup.jpg">    </p:cNvPr>
+          <p:cNvPr id="20" name="Image 0" descr="img/markers_closeup.jpg"/>
           <p:cNvPicPr>
             <a:picLocks noChangeAspect="1"/>
           </p:cNvPicPr>
           <p:nvPr/>
         </p:nvPicPr>
         <p:blipFill>
-          <a:blip r:embed="rId1"/>
-          <a:srcRect l="0" r="0" t="0" b="0"/>
+          <a:blip r:embed="rId3"/>
+          <a:srcRect/>
           <a:stretch/>
         </p:blipFill>
         <p:spPr>
@@ -2222,7 +2169,7 @@
             <a:avLst/>
           </a:prstGeom>
           <a:effectLst>
-            <a:outerShdw sx="100000" sy="100000" kx="0" ky="0" algn="bl" rotWithShape="0" blurRad="101600" dist="38100" dir="5400000">
+            <a:outerShdw blurRad="101600" dist="38100" dir="5400000" algn="bl" rotWithShape="0">
               <a:srgbClr val="20344A">
                 <a:alpha val="28000"/>
               </a:srgbClr>
@@ -2251,7 +2198,7 @@
           <a:bodyPr wrap="square" lIns="0" tIns="0" rIns="0" bIns="0" rtlCol="0" anchor="ctr"/>
           <a:lstStyle/>
           <a:p>
-            <a:pPr algn="ctr" indent="0" marL="0">
+            <a:pPr marL="0" indent="0" algn="ctr">
               <a:buNone/>
             </a:pPr>
             <a:r>
@@ -2271,15 +2218,15 @@
       </p:sp>
       <p:pic>
         <p:nvPicPr>
-          <p:cNvPr id="22" name="Image 1" descr="img/detection_overlay.jpg">    </p:cNvPr>
+          <p:cNvPr id="22" name="Image 1" descr="img/detection_overlay.jpg"/>
           <p:cNvPicPr>
             <a:picLocks noChangeAspect="1"/>
           </p:cNvPicPr>
           <p:nvPr/>
         </p:nvPicPr>
         <p:blipFill>
-          <a:blip r:embed="rId2"/>
-          <a:srcRect l="0" r="0" t="0" b="0"/>
+          <a:blip r:embed="rId4"/>
+          <a:srcRect/>
           <a:stretch/>
         </p:blipFill>
         <p:spPr>
@@ -2291,7 +2238,7 @@
             <a:avLst/>
           </a:prstGeom>
           <a:effectLst>
-            <a:outerShdw sx="100000" sy="100000" kx="0" ky="0" algn="bl" rotWithShape="0" blurRad="101600" dist="38100" dir="5400000">
+            <a:outerShdw blurRad="101600" dist="38100" dir="5400000" algn="bl" rotWithShape="0">
               <a:srgbClr val="20344A">
                 <a:alpha val="28000"/>
               </a:srgbClr>
@@ -2320,7 +2267,7 @@
           <a:bodyPr wrap="square" lIns="0" tIns="0" rIns="0" bIns="0" rtlCol="0" anchor="ctr"/>
           <a:lstStyle/>
           <a:p>
-            <a:pPr algn="ctr" indent="0" marL="0">
+            <a:pPr marL="0" indent="0" algn="ctr">
               <a:buNone/>
             </a:pPr>
             <a:r>
@@ -2354,6 +2301,7 @@
         <a:solidFill>
           <a:srgbClr val="F4F7FA"/>
         </a:solidFill>
+        <a:effectLst/>
       </p:bgPr>
     </p:bg>
     <p:spTree>
@@ -2391,7 +2339,7 @@
           <a:bodyPr wrap="square" lIns="0" tIns="0" rIns="0" bIns="0" rtlCol="0" anchor="ctr"/>
           <a:lstStyle/>
           <a:p>
-            <a:pPr indent="0" marL="0">
+            <a:pPr marL="0" indent="0">
               <a:buNone/>
             </a:pPr>
             <a:r>
@@ -2428,6 +2376,13 @@
           </a:solidFill>
           <a:ln/>
         </p:spPr>
+        <p:txBody>
+          <a:bodyPr/>
+          <a:lstStyle/>
+          <a:p>
+            <a:endParaRPr lang="en-US"/>
+          </a:p>
+        </p:txBody>
       </p:sp>
       <p:sp>
         <p:nvSpPr>
@@ -2450,7 +2405,7 @@
           <a:bodyPr wrap="square" lIns="0" tIns="0" rIns="0" bIns="0" rtlCol="0" anchor="ctr"/>
           <a:lstStyle/>
           <a:p>
-            <a:pPr indent="0" marL="0">
+            <a:pPr marL="0" indent="0">
               <a:lnSpc>
                 <a:spcPct val="114000"/>
               </a:lnSpc>
@@ -2497,13 +2452,20 @@
             <a:prstDash val="solid"/>
           </a:ln>
           <a:effectLst>
-            <a:outerShdw sx="100000" sy="100000" kx="0" ky="0" algn="bl" rotWithShape="0" blurRad="101600" dist="38100" dir="5400000">
+            <a:outerShdw blurRad="101600" dist="38100" dir="5400000" algn="bl" rotWithShape="0">
               <a:srgbClr val="20344A">
                 <a:alpha val="28000"/>
               </a:srgbClr>
             </a:outerShdw>
           </a:effectLst>
         </p:spPr>
+        <p:txBody>
+          <a:bodyPr/>
+          <a:lstStyle/>
+          <a:p>
+            <a:endParaRPr lang="en-US"/>
+          </a:p>
+        </p:txBody>
       </p:sp>
       <p:sp>
         <p:nvSpPr>
@@ -2524,6 +2486,13 @@
           </a:solidFill>
           <a:ln/>
         </p:spPr>
+        <p:txBody>
+          <a:bodyPr/>
+          <a:lstStyle/>
+          <a:p>
+            <a:endParaRPr lang="en-US"/>
+          </a:p>
+        </p:txBody>
       </p:sp>
       <p:sp>
         <p:nvSpPr>
@@ -2546,7 +2515,7 @@
           <a:bodyPr wrap="square" lIns="0" tIns="0" rIns="0" bIns="0" rtlCol="0" anchor="ctr"/>
           <a:lstStyle/>
           <a:p>
-            <a:pPr indent="0" marL="0">
+            <a:pPr marL="0" indent="0">
               <a:buNone/>
             </a:pPr>
             <a:r>
@@ -2585,7 +2554,7 @@
           <a:bodyPr wrap="square" lIns="0" tIns="0" rIns="0" bIns="0" rtlCol="0" anchor="ctr"/>
           <a:lstStyle/>
           <a:p>
-            <a:pPr indent="0" marL="0">
+            <a:pPr marL="0" indent="0">
               <a:buNone/>
             </a:pPr>
             <a:r>
@@ -2629,13 +2598,20 @@
             <a:prstDash val="solid"/>
           </a:ln>
           <a:effectLst>
-            <a:outerShdw sx="100000" sy="100000" kx="0" ky="0" algn="bl" rotWithShape="0" blurRad="101600" dist="38100" dir="5400000">
+            <a:outerShdw blurRad="101600" dist="38100" dir="5400000" algn="bl" rotWithShape="0">
               <a:srgbClr val="20344A">
                 <a:alpha val="28000"/>
               </a:srgbClr>
             </a:outerShdw>
           </a:effectLst>
         </p:spPr>
+        <p:txBody>
+          <a:bodyPr/>
+          <a:lstStyle/>
+          <a:p>
+            <a:endParaRPr lang="en-US"/>
+          </a:p>
+        </p:txBody>
       </p:sp>
       <p:sp>
         <p:nvSpPr>
@@ -2656,6 +2632,13 @@
           </a:solidFill>
           <a:ln/>
         </p:spPr>
+        <p:txBody>
+          <a:bodyPr/>
+          <a:lstStyle/>
+          <a:p>
+            <a:endParaRPr lang="en-US"/>
+          </a:p>
+        </p:txBody>
       </p:sp>
       <p:sp>
         <p:nvSpPr>
@@ -2678,7 +2661,7 @@
           <a:bodyPr wrap="square" lIns="0" tIns="0" rIns="0" bIns="0" rtlCol="0" anchor="ctr"/>
           <a:lstStyle/>
           <a:p>
-            <a:pPr indent="0" marL="0">
+            <a:pPr marL="0" indent="0">
               <a:buNone/>
             </a:pPr>
             <a:r>
@@ -2717,7 +2700,7 @@
           <a:bodyPr wrap="square" lIns="0" tIns="0" rIns="0" bIns="0" rtlCol="0" anchor="ctr"/>
           <a:lstStyle/>
           <a:p>
-            <a:pPr indent="0" marL="0">
+            <a:pPr marL="0" indent="0">
               <a:buNone/>
             </a:pPr>
             <a:r>
@@ -2761,13 +2744,20 @@
             <a:prstDash val="solid"/>
           </a:ln>
           <a:effectLst>
-            <a:outerShdw sx="100000" sy="100000" kx="0" ky="0" algn="bl" rotWithShape="0" blurRad="101600" dist="38100" dir="5400000">
+            <a:outerShdw blurRad="101600" dist="38100" dir="5400000" algn="bl" rotWithShape="0">
               <a:srgbClr val="20344A">
                 <a:alpha val="28000"/>
               </a:srgbClr>
             </a:outerShdw>
           </a:effectLst>
         </p:spPr>
+        <p:txBody>
+          <a:bodyPr/>
+          <a:lstStyle/>
+          <a:p>
+            <a:endParaRPr lang="en-US"/>
+          </a:p>
+        </p:txBody>
       </p:sp>
       <p:sp>
         <p:nvSpPr>
@@ -2788,6 +2778,13 @@
           </a:solidFill>
           <a:ln/>
         </p:spPr>
+        <p:txBody>
+          <a:bodyPr/>
+          <a:lstStyle/>
+          <a:p>
+            <a:endParaRPr lang="en-US"/>
+          </a:p>
+        </p:txBody>
       </p:sp>
       <p:sp>
         <p:nvSpPr>
@@ -2810,7 +2807,7 @@
           <a:bodyPr wrap="square" lIns="0" tIns="0" rIns="0" bIns="0" rtlCol="0" anchor="ctr"/>
           <a:lstStyle/>
           <a:p>
-            <a:pPr indent="0" marL="0">
+            <a:pPr marL="0" indent="0">
               <a:buNone/>
             </a:pPr>
             <a:r>
@@ -2849,7 +2846,7 @@
           <a:bodyPr wrap="square" lIns="0" tIns="0" rIns="0" bIns="0" rtlCol="0" anchor="ctr"/>
           <a:lstStyle/>
           <a:p>
-            <a:pPr indent="0" marL="0">
+            <a:pPr marL="0" indent="0">
               <a:buNone/>
             </a:pPr>
             <a:r>
@@ -2869,15 +2866,15 @@
       </p:sp>
       <p:pic>
         <p:nvPicPr>
-          <p:cNvPr id="17" name="Image 0" descr="img/calib_board.jpg">    </p:cNvPr>
+          <p:cNvPr id="17" name="Image 0" descr="img/calib_board.jpg"/>
           <p:cNvPicPr>
             <a:picLocks noChangeAspect="1"/>
           </p:cNvPicPr>
           <p:nvPr/>
         </p:nvPicPr>
         <p:blipFill>
-          <a:blip r:embed="rId1"/>
-          <a:srcRect l="0" r="0" t="0" b="0"/>
+          <a:blip r:embed="rId3"/>
+          <a:srcRect/>
           <a:stretch/>
         </p:blipFill>
         <p:spPr>
@@ -2889,7 +2886,7 @@
             <a:avLst/>
           </a:prstGeom>
           <a:effectLst>
-            <a:outerShdw sx="100000" sy="100000" kx="0" ky="0" algn="bl" rotWithShape="0" blurRad="101600" dist="38100" dir="5400000">
+            <a:outerShdw blurRad="101600" dist="38100" dir="5400000" algn="bl" rotWithShape="0">
               <a:srgbClr val="20344A">
                 <a:alpha val="28000"/>
               </a:srgbClr>
@@ -2918,7 +2915,7 @@
           <a:bodyPr wrap="square" lIns="0" tIns="0" rIns="0" bIns="0" rtlCol="0" anchor="ctr"/>
           <a:lstStyle/>
           <a:p>
-            <a:pPr algn="ctr" indent="0" marL="0">
+            <a:pPr marL="0" indent="0" algn="ctr">
               <a:buNone/>
             </a:pPr>
             <a:r>
@@ -2938,15 +2935,15 @@
       </p:sp>
       <p:pic>
         <p:nvPicPr>
-          <p:cNvPr id="19" name="Image 1" descr="img/calib_floor.jpg">    </p:cNvPr>
+          <p:cNvPr id="19" name="Image 1" descr="img/calib_floor.jpg"/>
           <p:cNvPicPr>
             <a:picLocks noChangeAspect="1"/>
           </p:cNvPicPr>
           <p:nvPr/>
         </p:nvPicPr>
         <p:blipFill>
-          <a:blip r:embed="rId2"/>
-          <a:srcRect l="0" r="0" t="0" b="0"/>
+          <a:blip r:embed="rId4"/>
+          <a:srcRect/>
           <a:stretch/>
         </p:blipFill>
         <p:spPr>
@@ -2958,7 +2955,7 @@
             <a:avLst/>
           </a:prstGeom>
           <a:effectLst>
-            <a:outerShdw sx="100000" sy="100000" kx="0" ky="0" algn="bl" rotWithShape="0" blurRad="101600" dist="38100" dir="5400000">
+            <a:outerShdw blurRad="101600" dist="38100" dir="5400000" algn="bl" rotWithShape="0">
               <a:srgbClr val="20344A">
                 <a:alpha val="28000"/>
               </a:srgbClr>
@@ -2987,7 +2984,7 @@
           <a:bodyPr wrap="square" lIns="0" tIns="0" rIns="0" bIns="0" rtlCol="0" anchor="ctr"/>
           <a:lstStyle/>
           <a:p>
-            <a:pPr algn="ctr" indent="0" marL="0">
+            <a:pPr marL="0" indent="0" algn="ctr">
               <a:buNone/>
             </a:pPr>
             <a:r>
@@ -3021,6 +3018,7 @@
         <a:solidFill>
           <a:srgbClr val="F4F7FA"/>
         </a:solidFill>
+        <a:effectLst/>
       </p:bgPr>
     </p:bg>
     <p:spTree>
@@ -3058,7 +3056,7 @@
           <a:bodyPr wrap="square" lIns="0" tIns="0" rIns="0" bIns="0" rtlCol="0" anchor="ctr"/>
           <a:lstStyle/>
           <a:p>
-            <a:pPr indent="0" marL="0">
+            <a:pPr marL="0" indent="0">
               <a:buNone/>
             </a:pPr>
             <a:r>
@@ -3095,18 +3093,25 @@
           </a:solidFill>
           <a:ln/>
         </p:spPr>
+        <p:txBody>
+          <a:bodyPr/>
+          <a:lstStyle/>
+          <a:p>
+            <a:endParaRPr lang="en-US"/>
+          </a:p>
+        </p:txBody>
       </p:sp>
       <p:pic>
         <p:nvPicPr>
-          <p:cNvPr id="4" name="Image 0" descr="img/clap.png">    </p:cNvPr>
+          <p:cNvPr id="4" name="Image 0" descr="img/clap.png"/>
           <p:cNvPicPr>
             <a:picLocks noChangeAspect="1"/>
           </p:cNvPicPr>
           <p:nvPr/>
         </p:nvPicPr>
         <p:blipFill>
-          <a:blip r:embed="rId1"/>
-          <a:srcRect l="0" r="0" t="0" b="0"/>
+          <a:blip r:embed="rId3"/>
+          <a:srcRect/>
           <a:stretch/>
         </p:blipFill>
         <p:spPr>
@@ -3138,13 +3143,20 @@
           </a:solidFill>
           <a:ln/>
           <a:effectLst>
-            <a:outerShdw sx="100000" sy="100000" kx="0" ky="0" algn="bl" rotWithShape="0" blurRad="101600" dist="38100" dir="5400000">
+            <a:outerShdw blurRad="101600" dist="38100" dir="5400000" algn="bl" rotWithShape="0">
               <a:srgbClr val="20344A">
                 <a:alpha val="28000"/>
               </a:srgbClr>
             </a:outerShdw>
           </a:effectLst>
         </p:spPr>
+        <p:txBody>
+          <a:bodyPr/>
+          <a:lstStyle/>
+          <a:p>
+            <a:endParaRPr lang="en-US"/>
+          </a:p>
+        </p:txBody>
       </p:sp>
       <p:sp>
         <p:nvSpPr>
@@ -3167,7 +3179,7 @@
           <a:bodyPr wrap="square" lIns="0" tIns="0" rIns="0" bIns="0" rtlCol="0" anchor="ctr"/>
           <a:lstStyle/>
           <a:p>
-            <a:pPr algn="ctr" indent="0" marL="0">
+            <a:pPr marL="0" indent="0" algn="ctr">
               <a:buNone/>
             </a:pPr>
             <a:r>
@@ -3206,7 +3218,7 @@
           <a:bodyPr wrap="square" lIns="0" tIns="0" rIns="0" bIns="0" rtlCol="0" anchor="ctr"/>
           <a:lstStyle/>
           <a:p>
-            <a:pPr indent="0" marL="0">
+            <a:pPr marL="0" indent="0">
               <a:buNone/>
             </a:pPr>
             <a:r>
@@ -3245,7 +3257,7 @@
           <a:bodyPr wrap="square" lIns="0" tIns="0" rIns="0" bIns="0" rtlCol="0" anchor="ctr"/>
           <a:lstStyle/>
           <a:p>
-            <a:pPr indent="0" marL="0">
+            <a:pPr marL="0" indent="0">
               <a:lnSpc>
                 <a:spcPct val="108000"/>
               </a:lnSpc>
@@ -3285,13 +3297,20 @@
           </a:solidFill>
           <a:ln/>
           <a:effectLst>
-            <a:outerShdw sx="100000" sy="100000" kx="0" ky="0" algn="bl" rotWithShape="0" blurRad="101600" dist="38100" dir="5400000">
+            <a:outerShdw blurRad="101600" dist="38100" dir="5400000" algn="bl" rotWithShape="0">
               <a:srgbClr val="20344A">
                 <a:alpha val="28000"/>
               </a:srgbClr>
             </a:outerShdw>
           </a:effectLst>
         </p:spPr>
+        <p:txBody>
+          <a:bodyPr/>
+          <a:lstStyle/>
+          <a:p>
+            <a:endParaRPr lang="en-US"/>
+          </a:p>
+        </p:txBody>
       </p:sp>
       <p:sp>
         <p:nvSpPr>
@@ -3314,7 +3333,7 @@
           <a:bodyPr wrap="square" lIns="0" tIns="0" rIns="0" bIns="0" rtlCol="0" anchor="ctr"/>
           <a:lstStyle/>
           <a:p>
-            <a:pPr algn="ctr" indent="0" marL="0">
+            <a:pPr marL="0" indent="0" algn="ctr">
               <a:buNone/>
             </a:pPr>
             <a:r>
@@ -3353,7 +3372,7 @@
           <a:bodyPr wrap="square" lIns="0" tIns="0" rIns="0" bIns="0" rtlCol="0" anchor="ctr"/>
           <a:lstStyle/>
           <a:p>
-            <a:pPr indent="0" marL="0">
+            <a:pPr marL="0" indent="0">
               <a:buNone/>
             </a:pPr>
             <a:r>
@@ -3392,7 +3411,7 @@
           <a:bodyPr wrap="square" lIns="0" tIns="0" rIns="0" bIns="0" rtlCol="0" anchor="ctr"/>
           <a:lstStyle/>
           <a:p>
-            <a:pPr indent="0" marL="0">
+            <a:pPr marL="0" indent="0">
               <a:lnSpc>
                 <a:spcPct val="108000"/>
               </a:lnSpc>
@@ -3432,13 +3451,20 @@
           </a:solidFill>
           <a:ln/>
           <a:effectLst>
-            <a:outerShdw sx="100000" sy="100000" kx="0" ky="0" algn="bl" rotWithShape="0" blurRad="101600" dist="38100" dir="5400000">
+            <a:outerShdw blurRad="101600" dist="38100" dir="5400000" algn="bl" rotWithShape="0">
               <a:srgbClr val="20344A">
                 <a:alpha val="28000"/>
               </a:srgbClr>
             </a:outerShdw>
           </a:effectLst>
         </p:spPr>
+        <p:txBody>
+          <a:bodyPr/>
+          <a:lstStyle/>
+          <a:p>
+            <a:endParaRPr lang="en-US"/>
+          </a:p>
+        </p:txBody>
       </p:sp>
       <p:sp>
         <p:nvSpPr>
@@ -3461,7 +3487,7 @@
           <a:bodyPr wrap="square" lIns="0" tIns="0" rIns="0" bIns="0" rtlCol="0" anchor="ctr"/>
           <a:lstStyle/>
           <a:p>
-            <a:pPr algn="ctr" indent="0" marL="0">
+            <a:pPr marL="0" indent="0" algn="ctr">
               <a:buNone/>
             </a:pPr>
             <a:r>
@@ -3500,7 +3526,7 @@
           <a:bodyPr wrap="square" lIns="0" tIns="0" rIns="0" bIns="0" rtlCol="0" anchor="ctr"/>
           <a:lstStyle/>
           <a:p>
-            <a:pPr indent="0" marL="0">
+            <a:pPr marL="0" indent="0">
               <a:buNone/>
             </a:pPr>
             <a:r>
@@ -3539,7 +3565,7 @@
           <a:bodyPr wrap="square" lIns="0" tIns="0" rIns="0" bIns="0" rtlCol="0" anchor="ctr"/>
           <a:lstStyle/>
           <a:p>
-            <a:pPr indent="0" marL="0">
+            <a:pPr marL="0" indent="0">
               <a:lnSpc>
                 <a:spcPct val="108000"/>
               </a:lnSpc>
@@ -3579,13 +3605,20 @@
           </a:solidFill>
           <a:ln/>
           <a:effectLst>
-            <a:outerShdw sx="100000" sy="100000" kx="0" ky="0" algn="bl" rotWithShape="0" blurRad="101600" dist="38100" dir="5400000">
+            <a:outerShdw blurRad="101600" dist="38100" dir="5400000" algn="bl" rotWithShape="0">
               <a:srgbClr val="20344A">
                 <a:alpha val="28000"/>
               </a:srgbClr>
             </a:outerShdw>
           </a:effectLst>
         </p:spPr>
+        <p:txBody>
+          <a:bodyPr/>
+          <a:lstStyle/>
+          <a:p>
+            <a:endParaRPr lang="en-US"/>
+          </a:p>
+        </p:txBody>
       </p:sp>
       <p:sp>
         <p:nvSpPr>
@@ -3608,7 +3641,7 @@
           <a:bodyPr wrap="square" lIns="0" tIns="0" rIns="0" bIns="0" rtlCol="0" anchor="ctr"/>
           <a:lstStyle/>
           <a:p>
-            <a:pPr algn="ctr" indent="0" marL="0">
+            <a:pPr marL="0" indent="0" algn="ctr">
               <a:buNone/>
             </a:pPr>
             <a:r>
@@ -3647,7 +3680,7 @@
           <a:bodyPr wrap="square" lIns="0" tIns="0" rIns="0" bIns="0" rtlCol="0" anchor="ctr"/>
           <a:lstStyle/>
           <a:p>
-            <a:pPr indent="0" marL="0">
+            <a:pPr marL="0" indent="0">
               <a:buNone/>
             </a:pPr>
             <a:r>
@@ -3686,7 +3719,7 @@
           <a:bodyPr wrap="square" lIns="0" tIns="0" rIns="0" bIns="0" rtlCol="0" anchor="ctr"/>
           <a:lstStyle/>
           <a:p>
-            <a:pPr indent="0" marL="0">
+            <a:pPr marL="0" indent="0">
               <a:lnSpc>
                 <a:spcPct val="108000"/>
               </a:lnSpc>
@@ -3728,13 +3761,20 @@
           </a:solidFill>
           <a:ln/>
           <a:effectLst>
-            <a:outerShdw sx="100000" sy="100000" kx="0" ky="0" algn="bl" rotWithShape="0" blurRad="101600" dist="38100" dir="5400000">
+            <a:outerShdw blurRad="101600" dist="38100" dir="5400000" algn="bl" rotWithShape="0">
               <a:srgbClr val="20344A">
                 <a:alpha val="28000"/>
               </a:srgbClr>
             </a:outerShdw>
           </a:effectLst>
         </p:spPr>
+        <p:txBody>
+          <a:bodyPr/>
+          <a:lstStyle/>
+          <a:p>
+            <a:endParaRPr lang="en-US"/>
+          </a:p>
+        </p:txBody>
       </p:sp>
       <p:sp>
         <p:nvSpPr>
@@ -3757,7 +3797,7 @@
           <a:bodyPr wrap="square" lIns="0" tIns="0" rIns="0" bIns="0" rtlCol="0" anchor="ctr"/>
           <a:lstStyle/>
           <a:p>
-            <a:pPr indent="0" marL="0">
+            <a:pPr marL="0" indent="0">
               <a:lnSpc>
                 <a:spcPct val="114000"/>
               </a:lnSpc>
@@ -3794,6 +3834,7 @@
         <a:solidFill>
           <a:srgbClr val="F4F7FA"/>
         </a:solidFill>
+        <a:effectLst/>
       </p:bgPr>
     </p:bg>
     <p:spTree>
@@ -3831,7 +3872,7 @@
           <a:bodyPr wrap="square" lIns="0" tIns="0" rIns="0" bIns="0" rtlCol="0" anchor="ctr"/>
           <a:lstStyle/>
           <a:p>
-            <a:pPr indent="0" marL="0">
+            <a:pPr marL="0" indent="0">
               <a:buNone/>
             </a:pPr>
             <a:r>
@@ -3868,18 +3909,25 @@
           </a:solidFill>
           <a:ln/>
         </p:spPr>
+        <p:txBody>
+          <a:bodyPr/>
+          <a:lstStyle/>
+          <a:p>
+            <a:endParaRPr lang="en-US"/>
+          </a:p>
+        </p:txBody>
       </p:sp>
       <p:pic>
         <p:nvPicPr>
-          <p:cNvPr id="4" name="Image 0" descr="img/trajectory.png">    </p:cNvPr>
+          <p:cNvPr id="4" name="Image 0" descr="img/trajectory.png"/>
           <p:cNvPicPr>
             <a:picLocks noChangeAspect="1"/>
           </p:cNvPicPr>
           <p:nvPr/>
         </p:nvPicPr>
         <p:blipFill>
-          <a:blip r:embed="rId1"/>
-          <a:srcRect l="0" r="0" t="0" b="0"/>
+          <a:blip r:embed="rId3"/>
+          <a:srcRect/>
           <a:stretch/>
         </p:blipFill>
         <p:spPr>
@@ -3891,7 +3939,7 @@
             <a:avLst/>
           </a:prstGeom>
           <a:effectLst>
-            <a:outerShdw sx="100000" sy="100000" kx="0" ky="0" algn="bl" rotWithShape="0" blurRad="101600" dist="38100" dir="5400000">
+            <a:outerShdw blurRad="101600" dist="38100" dir="5400000" algn="bl" rotWithShape="0">
               <a:srgbClr val="20344A">
                 <a:alpha val="28000"/>
               </a:srgbClr>
@@ -3918,13 +3966,20 @@
           </a:solidFill>
           <a:ln/>
           <a:effectLst>
-            <a:outerShdw sx="100000" sy="100000" kx="0" ky="0" algn="bl" rotWithShape="0" blurRad="101600" dist="38100" dir="5400000">
+            <a:outerShdw blurRad="101600" dist="38100" dir="5400000" algn="bl" rotWithShape="0">
               <a:srgbClr val="20344A">
                 <a:alpha val="28000"/>
               </a:srgbClr>
             </a:outerShdw>
           </a:effectLst>
         </p:spPr>
+        <p:txBody>
+          <a:bodyPr/>
+          <a:lstStyle/>
+          <a:p>
+            <a:endParaRPr lang="en-US"/>
+          </a:p>
+        </p:txBody>
       </p:sp>
       <p:sp>
         <p:nvSpPr>
@@ -3947,7 +4002,7 @@
           <a:bodyPr wrap="square" lIns="0" tIns="0" rIns="0" bIns="0" rtlCol="0" anchor="ctr"/>
           <a:lstStyle/>
           <a:p>
-            <a:pPr algn="ctr" indent="0" marL="0">
+            <a:pPr marL="0" indent="0" algn="ctr">
               <a:buNone/>
             </a:pPr>
             <a:r>
@@ -3986,7 +4041,7 @@
           <a:bodyPr wrap="square" lIns="0" tIns="0" rIns="0" bIns="0" rtlCol="0" anchor="ctr"/>
           <a:lstStyle/>
           <a:p>
-            <a:pPr indent="0" marL="0">
+            <a:pPr marL="0" indent="0">
               <a:buNone/>
             </a:pPr>
             <a:r>
@@ -4025,7 +4080,7 @@
           <a:bodyPr wrap="square" lIns="0" tIns="0" rIns="0" bIns="0" rtlCol="0" anchor="ctr"/>
           <a:lstStyle/>
           <a:p>
-            <a:pPr indent="0" marL="0">
+            <a:pPr marL="0" indent="0">
               <a:lnSpc>
                 <a:spcPct val="110000"/>
               </a:lnSpc>
@@ -4065,13 +4120,20 @@
           </a:solidFill>
           <a:ln/>
           <a:effectLst>
-            <a:outerShdw sx="100000" sy="100000" kx="0" ky="0" algn="bl" rotWithShape="0" blurRad="101600" dist="38100" dir="5400000">
+            <a:outerShdw blurRad="101600" dist="38100" dir="5400000" algn="bl" rotWithShape="0">
               <a:srgbClr val="20344A">
                 <a:alpha val="28000"/>
               </a:srgbClr>
             </a:outerShdw>
           </a:effectLst>
         </p:spPr>
+        <p:txBody>
+          <a:bodyPr/>
+          <a:lstStyle/>
+          <a:p>
+            <a:endParaRPr lang="en-US"/>
+          </a:p>
+        </p:txBody>
       </p:sp>
       <p:sp>
         <p:nvSpPr>
@@ -4094,7 +4156,7 @@
           <a:bodyPr wrap="square" lIns="0" tIns="0" rIns="0" bIns="0" rtlCol="0" anchor="ctr"/>
           <a:lstStyle/>
           <a:p>
-            <a:pPr algn="ctr" indent="0" marL="0">
+            <a:pPr marL="0" indent="0" algn="ctr">
               <a:buNone/>
             </a:pPr>
             <a:r>
@@ -4133,7 +4195,7 @@
           <a:bodyPr wrap="square" lIns="0" tIns="0" rIns="0" bIns="0" rtlCol="0" anchor="ctr"/>
           <a:lstStyle/>
           <a:p>
-            <a:pPr indent="0" marL="0">
+            <a:pPr marL="0" indent="0">
               <a:buNone/>
             </a:pPr>
             <a:r>
@@ -4172,7 +4234,7 @@
           <a:bodyPr wrap="square" lIns="0" tIns="0" rIns="0" bIns="0" rtlCol="0" anchor="ctr"/>
           <a:lstStyle/>
           <a:p>
-            <a:pPr indent="0" marL="0">
+            <a:pPr marL="0" indent="0">
               <a:lnSpc>
                 <a:spcPct val="110000"/>
               </a:lnSpc>
@@ -4212,13 +4274,20 @@
           </a:solidFill>
           <a:ln/>
           <a:effectLst>
-            <a:outerShdw sx="100000" sy="100000" kx="0" ky="0" algn="bl" rotWithShape="0" blurRad="101600" dist="38100" dir="5400000">
+            <a:outerShdw blurRad="101600" dist="38100" dir="5400000" algn="bl" rotWithShape="0">
               <a:srgbClr val="20344A">
                 <a:alpha val="28000"/>
               </a:srgbClr>
             </a:outerShdw>
           </a:effectLst>
         </p:spPr>
+        <p:txBody>
+          <a:bodyPr/>
+          <a:lstStyle/>
+          <a:p>
+            <a:endParaRPr lang="en-US"/>
+          </a:p>
+        </p:txBody>
       </p:sp>
       <p:sp>
         <p:nvSpPr>
@@ -4241,7 +4310,7 @@
           <a:bodyPr wrap="square" lIns="0" tIns="0" rIns="0" bIns="0" rtlCol="0" anchor="ctr"/>
           <a:lstStyle/>
           <a:p>
-            <a:pPr algn="ctr" indent="0" marL="0">
+            <a:pPr marL="0" indent="0" algn="ctr">
               <a:buNone/>
             </a:pPr>
             <a:r>
@@ -4280,7 +4349,7 @@
           <a:bodyPr wrap="square" lIns="0" tIns="0" rIns="0" bIns="0" rtlCol="0" anchor="ctr"/>
           <a:lstStyle/>
           <a:p>
-            <a:pPr indent="0" marL="0">
+            <a:pPr marL="0" indent="0">
               <a:buNone/>
             </a:pPr>
             <a:r>
@@ -4319,7 +4388,7 @@
           <a:bodyPr wrap="square" lIns="0" tIns="0" rIns="0" bIns="0" rtlCol="0" anchor="ctr"/>
           <a:lstStyle/>
           <a:p>
-            <a:pPr indent="0" marL="0">
+            <a:pPr marL="0" indent="0">
               <a:lnSpc>
                 <a:spcPct val="110000"/>
               </a:lnSpc>
@@ -4361,7 +4430,7 @@
           <a:bodyPr wrap="square" lIns="0" tIns="0" rIns="0" bIns="0" rtlCol="0" anchor="ctr"/>
           <a:lstStyle/>
           <a:p>
-            <a:pPr algn="ctr" indent="0" marL="0">
+            <a:pPr marL="0" indent="0" algn="ctr">
               <a:buNone/>
             </a:pPr>
             <a:r>
@@ -4389,12 +4458,202 @@
 
 <file path=ppt/slides/slide6.xml><?xml version="1.0" encoding="utf-8"?>
 <p:sld xmlns:a="http://schemas.openxmlformats.org/drawingml/2006/main" xmlns:r="http://schemas.openxmlformats.org/officeDocument/2006/relationships" xmlns:p="http://schemas.openxmlformats.org/presentationml/2006/main">
+  <p:cSld>
+    <p:spTree>
+      <p:nvGrpSpPr>
+        <p:cNvPr id="1" name="">
+          <a:extLst>
+            <a:ext uri="{FF2B5EF4-FFF2-40B4-BE49-F238E27FC236}">
+              <a16:creationId xmlns:a16="http://schemas.microsoft.com/office/drawing/2014/main" id="{1ECBC125-BF7F-749B-39D8-A3EAEA347BF8}"/>
+            </a:ext>
+          </a:extLst>
+        </p:cNvPr>
+        <p:cNvGrpSpPr/>
+        <p:nvPr/>
+      </p:nvGrpSpPr>
+      <p:grpSpPr>
+        <a:xfrm>
+          <a:off x="0" y="0"/>
+          <a:ext cx="0" cy="0"/>
+          <a:chOff x="0" y="0"/>
+          <a:chExt cx="0" cy="0"/>
+        </a:xfrm>
+      </p:grpSpPr>
+      <p:sp>
+        <p:nvSpPr>
+          <p:cNvPr id="2" name="Text 0">
+            <a:extLst>
+              <a:ext uri="{FF2B5EF4-FFF2-40B4-BE49-F238E27FC236}">
+                <a16:creationId xmlns:a16="http://schemas.microsoft.com/office/drawing/2014/main" id="{C06C357F-B934-EDCD-729E-55C74E05FA92}"/>
+              </a:ext>
+            </a:extLst>
+          </p:cNvPr>
+          <p:cNvSpPr/>
+          <p:nvPr/>
+        </p:nvSpPr>
+        <p:spPr>
+          <a:xfrm>
+            <a:off x="640080" y="457200"/>
+            <a:ext cx="10972800" cy="685800"/>
+          </a:xfrm>
+          <a:prstGeom prst="rect">
+            <a:avLst/>
+          </a:prstGeom>
+          <a:noFill/>
+          <a:ln/>
+        </p:spPr>
+        <p:txBody>
+          <a:bodyPr wrap="square" lIns="0" tIns="0" rIns="0" bIns="0" rtlCol="0" anchor="ctr"/>
+          <a:lstStyle/>
+          <a:p>
+            <a:pPr marL="0" indent="0">
+              <a:buNone/>
+            </a:pPr>
+            <a:r>
+              <a:rPr lang="en-US" sz="3100" b="1" dirty="0">
+                <a:solidFill>
+                  <a:srgbClr val="0F2A43"/>
+                </a:solidFill>
+                <a:latin typeface="Cambria" pitchFamily="34" charset="0"/>
+                <a:ea typeface="Cambria" pitchFamily="34" charset="-122"/>
+                <a:cs typeface="Cambria" pitchFamily="34" charset="-120"/>
+              </a:rPr>
+              <a:t>Result: 3D Foot-Clearance Trajectory</a:t>
+            </a:r>
+            <a:endParaRPr lang="en-US" sz="3100" dirty="0"/>
+          </a:p>
+        </p:txBody>
+      </p:sp>
+      <p:sp>
+        <p:nvSpPr>
+          <p:cNvPr id="3" name="Shape 1">
+            <a:extLst>
+              <a:ext uri="{FF2B5EF4-FFF2-40B4-BE49-F238E27FC236}">
+                <a16:creationId xmlns:a16="http://schemas.microsoft.com/office/drawing/2014/main" id="{6BC2CCDC-5AD3-14D8-37DE-931578DBB044}"/>
+              </a:ext>
+            </a:extLst>
+          </p:cNvPr>
+          <p:cNvSpPr/>
+          <p:nvPr/>
+        </p:nvSpPr>
+        <p:spPr>
+          <a:xfrm>
+            <a:off x="658368" y="1170432"/>
+            <a:ext cx="1371600" cy="54864"/>
+          </a:xfrm>
+          <a:prstGeom prst="rect">
+            <a:avLst/>
+          </a:prstGeom>
+          <a:solidFill>
+            <a:srgbClr val="2EC4B6"/>
+          </a:solidFill>
+          <a:ln/>
+        </p:spPr>
+        <p:txBody>
+          <a:bodyPr/>
+          <a:lstStyle/>
+          <a:p>
+            <a:endParaRPr lang="en-US"/>
+          </a:p>
+        </p:txBody>
+      </p:sp>
+      <p:sp>
+        <p:nvSpPr>
+          <p:cNvPr id="17" name="Text 14">
+            <a:extLst>
+              <a:ext uri="{FF2B5EF4-FFF2-40B4-BE49-F238E27FC236}">
+                <a16:creationId xmlns:a16="http://schemas.microsoft.com/office/drawing/2014/main" id="{E913C41F-B112-CECA-6886-85E91CE0CF62}"/>
+              </a:ext>
+            </a:extLst>
+          </p:cNvPr>
+          <p:cNvSpPr/>
+          <p:nvPr/>
+        </p:nvSpPr>
+        <p:spPr>
+          <a:xfrm>
+            <a:off x="4160520" y="6473952"/>
+            <a:ext cx="7498080" cy="320040"/>
+          </a:xfrm>
+          <a:prstGeom prst="rect">
+            <a:avLst/>
+          </a:prstGeom>
+          <a:noFill/>
+          <a:ln/>
+        </p:spPr>
+        <p:txBody>
+          <a:bodyPr wrap="square" lIns="0" tIns="0" rIns="0" bIns="0" rtlCol="0" anchor="ctr"/>
+          <a:lstStyle/>
+          <a:p>
+            <a:pPr marL="0" indent="0" algn="ctr">
+              <a:buNone/>
+            </a:pPr>
+            <a:r>
+              <a:rPr lang="en-US" sz="1050" i="1" dirty="0">
+                <a:solidFill>
+                  <a:srgbClr val="5C6B7A"/>
+                </a:solidFill>
+                <a:latin typeface="Calibri" pitchFamily="34" charset="0"/>
+                <a:ea typeface="Calibri" pitchFamily="34" charset="-122"/>
+                <a:cs typeface="Calibri" pitchFamily="34" charset="-120"/>
+              </a:rPr>
+              <a:t>Top: toe/heel height over time (clearance).  Bottom: toe–heel distance stays flat = clean 3D.</a:t>
+            </a:r>
+            <a:endParaRPr lang="en-US" sz="1050" dirty="0"/>
+          </a:p>
+        </p:txBody>
+      </p:sp>
+      <p:pic>
+        <p:nvPicPr>
+          <p:cNvPr id="19" name="Picture 18">
+            <a:extLst>
+              <a:ext uri="{FF2B5EF4-FFF2-40B4-BE49-F238E27FC236}">
+                <a16:creationId xmlns:a16="http://schemas.microsoft.com/office/drawing/2014/main" id="{351C2033-A207-3DA1-BA03-E3811F98E9C9}"/>
+              </a:ext>
+            </a:extLst>
+          </p:cNvPr>
+          <p:cNvPicPr>
+            <a:picLocks noChangeAspect="1"/>
+          </p:cNvPicPr>
+          <p:nvPr/>
+        </p:nvPicPr>
+        <p:blipFill>
+          <a:blip r:embed="rId3"/>
+          <a:stretch>
+            <a:fillRect/>
+          </a:stretch>
+        </p:blipFill>
+        <p:spPr>
+          <a:xfrm>
+            <a:off x="1006151" y="1170432"/>
+            <a:ext cx="10179698" cy="5131320"/>
+          </a:xfrm>
+          <a:prstGeom prst="rect">
+            <a:avLst/>
+          </a:prstGeom>
+        </p:spPr>
+      </p:pic>
+    </p:spTree>
+    <p:extLst>
+      <p:ext uri="{BB962C8B-B14F-4D97-AF65-F5344CB8AC3E}">
+        <p14:creationId xmlns:p14="http://schemas.microsoft.com/office/powerpoint/2010/main" val="3564488244"/>
+      </p:ext>
+    </p:extLst>
+  </p:cSld>
+  <p:clrMapOvr>
+    <a:masterClrMapping/>
+  </p:clrMapOvr>
+</p:sld>
+</file>
+
+<file path=ppt/slides/slide7.xml><?xml version="1.0" encoding="utf-8"?>
+<p:sld xmlns:a="http://schemas.openxmlformats.org/drawingml/2006/main" xmlns:r="http://schemas.openxmlformats.org/officeDocument/2006/relationships" xmlns:p="http://schemas.openxmlformats.org/presentationml/2006/main">
   <p:cSld name="Slide 6">
     <p:bg>
       <p:bgPr>
         <a:solidFill>
           <a:srgbClr val="0F2A43"/>
         </a:solidFill>
+        <a:effectLst/>
       </p:bgPr>
     </p:bg>
     <p:spTree>
@@ -4432,7 +4691,7 @@
           <a:bodyPr wrap="square" lIns="0" tIns="0" rIns="0" bIns="0" rtlCol="0" anchor="ctr"/>
           <a:lstStyle/>
           <a:p>
-            <a:pPr indent="0" marL="0">
+            <a:pPr marL="0" indent="0">
               <a:buNone/>
             </a:pPr>
             <a:r>
@@ -4469,6 +4728,13 @@
           </a:solidFill>
           <a:ln/>
         </p:spPr>
+        <p:txBody>
+          <a:bodyPr/>
+          <a:lstStyle/>
+          <a:p>
+            <a:endParaRPr lang="en-US"/>
+          </a:p>
+        </p:txBody>
       </p:sp>
       <p:sp>
         <p:nvSpPr>
@@ -4491,11 +4757,11 @@
           <a:bodyPr wrap="square" lIns="0" tIns="0" rIns="0" bIns="0" rtlCol="0" anchor="ctr"/>
           <a:lstStyle/>
           <a:p>
-            <a:pPr indent="0" marL="0">
+            <a:pPr marL="0" indent="0">
               <a:buNone/>
             </a:pPr>
             <a:r>
-              <a:rPr lang="en-US" sz="1400" b="1" spc="300" kern="0" dirty="0">
+              <a:rPr lang="en-US" sz="1400" b="1" kern="0" spc="300" dirty="0">
                 <a:solidFill>
                   <a:srgbClr val="2EC4B6"/>
                 </a:solidFill>
@@ -4678,13 +4944,20 @@
           </a:solidFill>
           <a:ln/>
           <a:effectLst>
-            <a:outerShdw sx="100000" sy="100000" kx="0" ky="0" algn="bl" rotWithShape="0" blurRad="101600" dist="38100" dir="5400000">
+            <a:outerShdw blurRad="101600" dist="38100" dir="5400000" algn="bl" rotWithShape="0">
               <a:srgbClr val="20344A">
                 <a:alpha val="28000"/>
               </a:srgbClr>
             </a:outerShdw>
           </a:effectLst>
         </p:spPr>
+        <p:txBody>
+          <a:bodyPr/>
+          <a:lstStyle/>
+          <a:p>
+            <a:endParaRPr lang="en-US"/>
+          </a:p>
+        </p:txBody>
       </p:sp>
       <p:sp>
         <p:nvSpPr>
@@ -4707,11 +4980,11 @@
           <a:bodyPr wrap="square" lIns="0" tIns="0" rIns="0" bIns="0" rtlCol="0" anchor="ctr"/>
           <a:lstStyle/>
           <a:p>
-            <a:pPr indent="0" marL="0">
+            <a:pPr marL="0" indent="0">
               <a:buNone/>
             </a:pPr>
             <a:r>
-              <a:rPr lang="en-US" sz="1400" b="1" spc="300" kern="0" dirty="0">
+              <a:rPr lang="en-US" sz="1400" b="1" kern="0" spc="300" dirty="0">
                 <a:solidFill>
                   <a:srgbClr val="2EC4B6"/>
                 </a:solidFill>
@@ -4852,7 +5125,7 @@
           <a:bodyPr wrap="square" lIns="0" tIns="0" rIns="0" bIns="0" rtlCol="0" anchor="ctr"/>
           <a:lstStyle/>
           <a:p>
-            <a:pPr indent="0" marL="0">
+            <a:pPr marL="0" indent="0">
               <a:lnSpc>
                 <a:spcPct val="108000"/>
               </a:lnSpc>
@@ -5174,4 +5447,319 @@
     </a:ext>
   </a:extLst>
 </a:theme>
+</file>
+
+<file path=ppt/theme/theme2.xml><?xml version="1.0" encoding="utf-8"?>
+<a:theme xmlns:a="http://schemas.openxmlformats.org/drawingml/2006/main" name="Office Theme">
+  <a:themeElements>
+    <a:clrScheme name="Office">
+      <a:dk1>
+        <a:sysClr val="windowText" lastClr="000000"/>
+      </a:dk1>
+      <a:lt1>
+        <a:sysClr val="window" lastClr="FFFFFF"/>
+      </a:lt1>
+      <a:dk2>
+        <a:srgbClr val="0E2841"/>
+      </a:dk2>
+      <a:lt2>
+        <a:srgbClr val="E8E8E8"/>
+      </a:lt2>
+      <a:accent1>
+        <a:srgbClr val="156082"/>
+      </a:accent1>
+      <a:accent2>
+        <a:srgbClr val="E97132"/>
+      </a:accent2>
+      <a:accent3>
+        <a:srgbClr val="196B24"/>
+      </a:accent3>
+      <a:accent4>
+        <a:srgbClr val="0F9ED5"/>
+      </a:accent4>
+      <a:accent5>
+        <a:srgbClr val="A02B93"/>
+      </a:accent5>
+      <a:accent6>
+        <a:srgbClr val="4EA72E"/>
+      </a:accent6>
+      <a:hlink>
+        <a:srgbClr val="467886"/>
+      </a:hlink>
+      <a:folHlink>
+        <a:srgbClr val="96607D"/>
+      </a:folHlink>
+    </a:clrScheme>
+    <a:fontScheme name="Office">
+      <a:majorFont>
+        <a:latin typeface="Aptos Display" panose="02110004020202020204"/>
+        <a:ea typeface=""/>
+        <a:cs typeface=""/>
+        <a:font script="Jpan" typeface="游ゴシック Light"/>
+        <a:font script="Hang" typeface="맑은 고딕"/>
+        <a:font script="Hans" typeface="等线 Light"/>
+        <a:font script="Hant" typeface="新細明體"/>
+        <a:font script="Arab" typeface="Times New Roman"/>
+        <a:font script="Hebr" typeface="Times New Roman"/>
+        <a:font script="Thai" typeface="Angsana New"/>
+        <a:font script="Ethi" typeface="Nyala"/>
+        <a:font script="Beng" typeface="Vrinda"/>
+        <a:font script="Gujr" typeface="Shruti"/>
+        <a:font script="Khmr" typeface="MoolBoran"/>
+        <a:font script="Knda" typeface="Tunga"/>
+        <a:font script="Guru" typeface="Raavi"/>
+        <a:font script="Cans" typeface="Euphemia"/>
+        <a:font script="Cher" typeface="Plantagenet Cherokee"/>
+        <a:font script="Yiii" typeface="Microsoft Yi Baiti"/>
+        <a:font script="Tibt" typeface="Microsoft Himalaya"/>
+        <a:font script="Thaa" typeface="MV Boli"/>
+        <a:font script="Deva" typeface="Mangal"/>
+        <a:font script="Telu" typeface="Gautami"/>
+        <a:font script="Taml" typeface="Latha"/>
+        <a:font script="Syrc" typeface="Estrangelo Edessa"/>
+        <a:font script="Orya" typeface="Kalinga"/>
+        <a:font script="Mlym" typeface="Kartika"/>
+        <a:font script="Laoo" typeface="DokChampa"/>
+        <a:font script="Sinh" typeface="Iskoola Pota"/>
+        <a:font script="Mong" typeface="Mongolian Baiti"/>
+        <a:font script="Viet" typeface="Times New Roman"/>
+        <a:font script="Uigh" typeface="Microsoft Uighur"/>
+        <a:font script="Geor" typeface="Sylfaen"/>
+        <a:font script="Armn" typeface="Arial"/>
+        <a:font script="Bugi" typeface="Leelawadee UI"/>
+        <a:font script="Bopo" typeface="Microsoft JhengHei"/>
+        <a:font script="Java" typeface="Javanese Text"/>
+        <a:font script="Lisu" typeface="Segoe UI"/>
+        <a:font script="Mymr" typeface="Myanmar Text"/>
+        <a:font script="Nkoo" typeface="Ebrima"/>
+        <a:font script="Olck" typeface="Nirmala UI"/>
+        <a:font script="Osma" typeface="Ebrima"/>
+        <a:font script="Phag" typeface="Phagspa"/>
+        <a:font script="Syrn" typeface="Estrangelo Edessa"/>
+        <a:font script="Syrj" typeface="Estrangelo Edessa"/>
+        <a:font script="Syre" typeface="Estrangelo Edessa"/>
+        <a:font script="Sora" typeface="Nirmala UI"/>
+        <a:font script="Tale" typeface="Microsoft Tai Le"/>
+        <a:font script="Talu" typeface="Microsoft New Tai Lue"/>
+        <a:font script="Tfng" typeface="Ebrima"/>
+      </a:majorFont>
+      <a:minorFont>
+        <a:latin typeface="Aptos" panose="02110004020202020204"/>
+        <a:ea typeface=""/>
+        <a:cs typeface=""/>
+        <a:font script="Jpan" typeface="游ゴシック"/>
+        <a:font script="Hang" typeface="맑은 고딕"/>
+        <a:font script="Hans" typeface="等线"/>
+        <a:font script="Hant" typeface="新細明體"/>
+        <a:font script="Arab" typeface="Arial"/>
+        <a:font script="Hebr" typeface="Arial"/>
+        <a:font script="Thai" typeface="Cordia New"/>
+        <a:font script="Ethi" typeface="Nyala"/>
+        <a:font script="Beng" typeface="Vrinda"/>
+        <a:font script="Gujr" typeface="Shruti"/>
+        <a:font script="Khmr" typeface="DaunPenh"/>
+        <a:font script="Knda" typeface="Tunga"/>
+        <a:font script="Guru" typeface="Raavi"/>
+        <a:font script="Cans" typeface="Euphemia"/>
+        <a:font script="Cher" typeface="Plantagenet Cherokee"/>
+        <a:font script="Yiii" typeface="Microsoft Yi Baiti"/>
+        <a:font script="Tibt" typeface="Microsoft Himalaya"/>
+        <a:font script="Thaa" typeface="MV Boli"/>
+        <a:font script="Deva" typeface="Mangal"/>
+        <a:font script="Telu" typeface="Gautami"/>
+        <a:font script="Taml" typeface="Latha"/>
+        <a:font script="Syrc" typeface="Estrangelo Edessa"/>
+        <a:font script="Orya" typeface="Kalinga"/>
+        <a:font script="Mlym" typeface="Kartika"/>
+        <a:font script="Laoo" typeface="DokChampa"/>
+        <a:font script="Sinh" typeface="Iskoola Pota"/>
+        <a:font script="Mong" typeface="Mongolian Baiti"/>
+        <a:font script="Viet" typeface="Arial"/>
+        <a:font script="Uigh" typeface="Microsoft Uighur"/>
+        <a:font script="Geor" typeface="Sylfaen"/>
+        <a:font script="Armn" typeface="Arial"/>
+        <a:font script="Bugi" typeface="Leelawadee UI"/>
+        <a:font script="Bopo" typeface="Microsoft JhengHei"/>
+        <a:font script="Java" typeface="Javanese Text"/>
+        <a:font script="Lisu" typeface="Segoe UI"/>
+        <a:font script="Mymr" typeface="Myanmar Text"/>
+        <a:font script="Nkoo" typeface="Ebrima"/>
+        <a:font script="Olck" typeface="Nirmala UI"/>
+        <a:font script="Osma" typeface="Ebrima"/>
+        <a:font script="Phag" typeface="Phagspa"/>
+        <a:font script="Syrn" typeface="Estrangelo Edessa"/>
+        <a:font script="Syrj" typeface="Estrangelo Edessa"/>
+        <a:font script="Syre" typeface="Estrangelo Edessa"/>
+        <a:font script="Sora" typeface="Nirmala UI"/>
+        <a:font script="Tale" typeface="Microsoft Tai Le"/>
+        <a:font script="Talu" typeface="Microsoft New Tai Lue"/>
+        <a:font script="Tfng" typeface="Ebrima"/>
+      </a:minorFont>
+    </a:fontScheme>
+    <a:fmtScheme name="Office">
+      <a:fillStyleLst>
+        <a:solidFill>
+          <a:schemeClr val="phClr"/>
+        </a:solidFill>
+        <a:gradFill rotWithShape="1">
+          <a:gsLst>
+            <a:gs pos="0">
+              <a:schemeClr val="phClr">
+                <a:lumMod val="110000"/>
+                <a:satMod val="105000"/>
+                <a:tint val="67000"/>
+              </a:schemeClr>
+            </a:gs>
+            <a:gs pos="50000">
+              <a:schemeClr val="phClr">
+                <a:lumMod val="105000"/>
+                <a:satMod val="103000"/>
+                <a:tint val="73000"/>
+              </a:schemeClr>
+            </a:gs>
+            <a:gs pos="100000">
+              <a:schemeClr val="phClr">
+                <a:lumMod val="105000"/>
+                <a:satMod val="109000"/>
+                <a:tint val="81000"/>
+              </a:schemeClr>
+            </a:gs>
+          </a:gsLst>
+          <a:lin ang="5400000" scaled="0"/>
+        </a:gradFill>
+        <a:gradFill rotWithShape="1">
+          <a:gsLst>
+            <a:gs pos="0">
+              <a:schemeClr val="phClr">
+                <a:satMod val="103000"/>
+                <a:lumMod val="102000"/>
+                <a:tint val="94000"/>
+              </a:schemeClr>
+            </a:gs>
+            <a:gs pos="50000">
+              <a:schemeClr val="phClr">
+                <a:satMod val="110000"/>
+                <a:lumMod val="100000"/>
+                <a:shade val="100000"/>
+              </a:schemeClr>
+            </a:gs>
+            <a:gs pos="100000">
+              <a:schemeClr val="phClr">
+                <a:lumMod val="99000"/>
+                <a:satMod val="120000"/>
+                <a:shade val="78000"/>
+              </a:schemeClr>
+            </a:gs>
+          </a:gsLst>
+          <a:lin ang="5400000" scaled="0"/>
+        </a:gradFill>
+      </a:fillStyleLst>
+      <a:lnStyleLst>
+        <a:ln w="12700" cap="flat" cmpd="sng" algn="ctr">
+          <a:solidFill>
+            <a:schemeClr val="phClr"/>
+          </a:solidFill>
+          <a:prstDash val="solid"/>
+          <a:miter lim="800000"/>
+        </a:ln>
+        <a:ln w="19050" cap="flat" cmpd="sng" algn="ctr">
+          <a:solidFill>
+            <a:schemeClr val="phClr"/>
+          </a:solidFill>
+          <a:prstDash val="solid"/>
+          <a:miter lim="800000"/>
+        </a:ln>
+        <a:ln w="25400" cap="flat" cmpd="sng" algn="ctr">
+          <a:solidFill>
+            <a:schemeClr val="phClr"/>
+          </a:solidFill>
+          <a:prstDash val="solid"/>
+          <a:miter lim="800000"/>
+        </a:ln>
+      </a:lnStyleLst>
+      <a:effectStyleLst>
+        <a:effectStyle>
+          <a:effectLst/>
+        </a:effectStyle>
+        <a:effectStyle>
+          <a:effectLst/>
+        </a:effectStyle>
+        <a:effectStyle>
+          <a:effectLst>
+            <a:outerShdw blurRad="57150" dist="19050" dir="5400000" algn="ctr" rotWithShape="0">
+              <a:srgbClr val="000000">
+                <a:alpha val="63000"/>
+              </a:srgbClr>
+            </a:outerShdw>
+          </a:effectLst>
+        </a:effectStyle>
+      </a:effectStyleLst>
+      <a:bgFillStyleLst>
+        <a:solidFill>
+          <a:schemeClr val="phClr"/>
+        </a:solidFill>
+        <a:solidFill>
+          <a:schemeClr val="phClr">
+            <a:tint val="95000"/>
+            <a:satMod val="170000"/>
+          </a:schemeClr>
+        </a:solidFill>
+        <a:gradFill rotWithShape="1">
+          <a:gsLst>
+            <a:gs pos="0">
+              <a:schemeClr val="phClr">
+                <a:tint val="93000"/>
+                <a:satMod val="150000"/>
+                <a:shade val="98000"/>
+                <a:lumMod val="102000"/>
+              </a:schemeClr>
+            </a:gs>
+            <a:gs pos="50000">
+              <a:schemeClr val="phClr">
+                <a:tint val="98000"/>
+                <a:satMod val="130000"/>
+                <a:shade val="90000"/>
+                <a:lumMod val="103000"/>
+              </a:schemeClr>
+            </a:gs>
+            <a:gs pos="100000">
+              <a:schemeClr val="phClr">
+                <a:shade val="63000"/>
+                <a:satMod val="120000"/>
+              </a:schemeClr>
+            </a:gs>
+          </a:gsLst>
+          <a:lin ang="5400000" scaled="0"/>
+        </a:gradFill>
+      </a:bgFillStyleLst>
+    </a:fmtScheme>
+  </a:themeElements>
+  <a:objectDefaults>
+    <a:lnDef>
+      <a:spPr/>
+      <a:bodyPr/>
+      <a:lstStyle/>
+      <a:style>
+        <a:lnRef idx="2">
+          <a:schemeClr val="accent1"/>
+        </a:lnRef>
+        <a:fillRef idx="0">
+          <a:schemeClr val="accent1"/>
+        </a:fillRef>
+        <a:effectRef idx="1">
+          <a:schemeClr val="accent1"/>
+        </a:effectRef>
+        <a:fontRef idx="minor">
+          <a:schemeClr val="tx1"/>
+        </a:fontRef>
+      </a:style>
+    </a:lnDef>
+  </a:objectDefaults>
+  <a:extraClrSchemeLst/>
+  <a:extLst>
+    <a:ext uri="{05A4C25C-085E-4340-85A3-A5531E510DB2}">
+      <thm15:themeFamily xmlns:thm15="http://schemas.microsoft.com/office/thememl/2012/main" name="Office Theme" id="{2E142A2C-CD16-42D6-873A-C26D2A0506FA}" vid="{1BDDFF52-6CD6-40A5-AB3C-68EB2F1E4D0A}"/>
+    </a:ext>
+  </a:extLst>
+</a:theme>
 </file>
</xml_diff>